<commit_message>
Add family-definition slides with real gorilla example
Slides use Family 45 (LOC101124778) from the refined catalog to illustrate:

1) the definition of a multi-copy gene family, 2) the birdseye quasi-clique view,

3) a zoom on one copy showing its two isoforms.

Co-Authored-By: Kimi <noreply@anthropic.com>
</commit_message>
<xml_diff>
--- a/bench/family_definition_slides.pptx
+++ b/bench/family_definition_slides.pptx
@@ -8,21 +8,6 @@
     <p:sldId id="256" r:id="rId7"/>
     <p:sldId id="257" r:id="rId8"/>
     <p:sldId id="258" r:id="rId9"/>
-    <p:sldId id="259" r:id="rId10"/>
-    <p:sldId id="260" r:id="rId11"/>
-    <p:sldId id="261" r:id="rId12"/>
-    <p:sldId id="262" r:id="rId13"/>
-    <p:sldId id="263" r:id="rId14"/>
-    <p:sldId id="264" r:id="rId15"/>
-    <p:sldId id="265" r:id="rId16"/>
-    <p:sldId id="266" r:id="rId17"/>
-    <p:sldId id="267" r:id="rId18"/>
-    <p:sldId id="268" r:id="rId19"/>
-    <p:sldId id="269" r:id="rId20"/>
-    <p:sldId id="270" r:id="rId21"/>
-    <p:sldId id="271" r:id="rId22"/>
-    <p:sldId id="272" r:id="rId23"/>
-    <p:sldId id="273" r:id="rId24"/>
   </p:sldIdLst>
   <p:sldSz cx="12188952" cy="6858000" type="screen4x3"/>
   <p:notesSz cx="6858000" cy="9144000"/>
@@ -3113,499 +3098,7 @@
         </p:nvSpPr>
         <p:spPr>
           <a:xfrm>
-            <a:off x="548640" y="1828800"/>
-            <a:ext cx="11064240" cy="1828800"/>
-          </a:xfrm>
-          <a:prstGeom prst="rect">
-            <a:avLst/>
-          </a:prstGeom>
-          <a:noFill/>
-        </p:spPr>
-        <p:txBody>
-          <a:bodyPr wrap="square">
-            <a:spAutoFit/>
-          </a:bodyPr>
-          <a:lstStyle/>
-          <a:p>
-            <a:pPr>
-              <a:defRPr sz="3400" b="1">
-                <a:solidFill>
-                  <a:srgbClr val="1F2D5A"/>
-                </a:solidFill>
-              </a:defRPr>
-            </a:pPr>
-            <a:r>
-              <a:t>Defining a multi-copy gene family at the RNA level</a:t>
-            </a:r>
-          </a:p>
-          <a:p>
-            <a:pPr>
-              <a:defRPr sz="2000">
-                <a:solidFill>
-                  <a:srgbClr val="127A6E"/>
-                </a:solidFill>
-              </a:defRPr>
-            </a:pPr>
-            <a:r>
-              <a:t>A read-conflict graph:  recent paralogy  ∩  read-confusability</a:t>
-            </a:r>
-          </a:p>
-        </p:txBody>
-      </p:sp>
-      <p:sp>
-        <p:nvSpPr>
-          <p:cNvPr id="3" name="TextBox 2"/>
-          <p:cNvSpPr txBox="1"/>
-          <p:nvPr/>
-        </p:nvSpPr>
-        <p:spPr>
-          <a:xfrm>
-            <a:off x="548640" y="6126480"/>
-            <a:ext cx="11064240" cy="457200"/>
-          </a:xfrm>
-          <a:prstGeom prst="rect">
-            <a:avLst/>
-          </a:prstGeom>
-          <a:noFill/>
-        </p:spPr>
-        <p:txBody>
-          <a:bodyPr wrap="none">
-            <a:spAutoFit/>
-          </a:bodyPr>
-          <a:lstStyle/>
-          <a:p>
-            <a:pPr>
-              <a:defRPr sz="1200">
-                <a:solidFill>
-                  <a:srgbClr val="444444"/>
-                </a:solidFill>
-              </a:defRPr>
-            </a:pPr>
-            <a:r>
-              <a:t>GGO HiFi IsoSeq · de-tie criterion · TP=7 TN=10 FP=0 FN=0 · genome-wide validated</a:t>
-            </a:r>
-          </a:p>
-        </p:txBody>
-      </p:sp>
-    </p:spTree>
-  </p:cSld>
-  <p:clrMapOvr>
-    <a:masterClrMapping/>
-  </p:clrMapOvr>
-</p:sld>
-</file>
-
-<file path=ppt/slides/slide10.xml><?xml version="1.0" encoding="utf-8"?>
-<p:sld xmlns:a="http://schemas.openxmlformats.org/drawingml/2006/main" xmlns:p="http://schemas.openxmlformats.org/presentationml/2006/main" xmlns:r="http://schemas.openxmlformats.org/officeDocument/2006/relationships">
-  <p:cSld>
-    <p:spTree>
-      <p:nvGrpSpPr>
-        <p:cNvPr id="1" name=""/>
-        <p:cNvGrpSpPr/>
-        <p:nvPr/>
-      </p:nvGrpSpPr>
-      <p:grpSpPr/>
-      <p:sp>
-        <p:nvSpPr>
-          <p:cNvPr id="2" name="TextBox 1"/>
-          <p:cNvSpPr txBox="1"/>
-          <p:nvPr/>
-        </p:nvSpPr>
-        <p:spPr>
-          <a:xfrm>
-            <a:off x="457200" y="274320"/>
-            <a:ext cx="11247120" cy="822960"/>
-          </a:xfrm>
-          <a:prstGeom prst="rect">
-            <a:avLst/>
-          </a:prstGeom>
-          <a:noFill/>
-        </p:spPr>
-        <p:txBody>
-          <a:bodyPr wrap="none">
-            <a:spAutoFit/>
-          </a:bodyPr>
-          <a:lstStyle/>
-          <a:p>
-            <a:pPr>
-              <a:defRPr sz="2600" b="1">
-                <a:solidFill>
-                  <a:srgbClr val="1F2D5A"/>
-                </a:solidFill>
-              </a:defRPr>
-            </a:pPr>
-            <a:r>
-              <a:t>Three structural robustnesses — strong on the tested panel (homology guard at scale)</a:t>
-            </a:r>
-          </a:p>
-        </p:txBody>
-      </p:sp>
-      <p:sp>
-        <p:nvSpPr>
-          <p:cNvPr id="3" name="TextBox 2"/>
-          <p:cNvSpPr txBox="1"/>
-          <p:nvPr/>
-        </p:nvSpPr>
-        <p:spPr>
-          <a:xfrm>
-            <a:off x="548640" y="1280160"/>
-            <a:ext cx="11064240" cy="4937760"/>
-          </a:xfrm>
-          <a:prstGeom prst="rect">
-            <a:avLst/>
-          </a:prstGeom>
-          <a:noFill/>
-        </p:spPr>
-        <p:txBody>
-          <a:bodyPr wrap="square">
-            <a:spAutoFit/>
-          </a:bodyPr>
-          <a:lstStyle/>
-          <a:p>
-            <a:pPr>
-              <a:spcAft>
-                <a:spcPts val="700"/>
-              </a:spcAft>
-              <a:defRPr sz="1800">
-                <a:solidFill>
-                  <a:srgbClr val="222222"/>
-                </a:solidFill>
-              </a:defRPr>
-            </a:pPr>
-            <a:r>
-              <a:t>•  Domain-sharers: single-valued best-overlap → 0 cross-locus edges (verified 0/192, 0/429 on the panel).</a:t>
-            </a:r>
-          </a:p>
-          <a:p>
-            <a:pPr>
-              <a:spcAft>
-                <a:spcPts val="700"/>
-              </a:spcAft>
-              <a:defRPr sz="1800">
-                <a:solidFill>
-                  <a:srgbClr val="222222"/>
-                </a:solidFill>
-              </a:defRPr>
-            </a:pPr>
-            <a:r>
-              <a:t>•  Over-split fragments: co-positioned isoforms share no conflicting read.</a:t>
-            </a:r>
-          </a:p>
-          <a:p>
-            <a:pPr>
-              <a:spcAft>
-                <a:spcPts val="700"/>
-              </a:spcAft>
-              <a:defRPr sz="1500">
-                <a:solidFill>
-                  <a:srgbClr val="222222"/>
-                </a:solidFill>
-              </a:defRPr>
-            </a:pPr>
-            <a:r>
-              <a:t>      –  a sequence-SIMILARITY definition made 42% false families here; the conflict definition needs no SIMILARITY guard.</a:t>
-            </a:r>
-          </a:p>
-          <a:p>
-            <a:pPr>
-              <a:spcAft>
-                <a:spcPts val="700"/>
-              </a:spcAft>
-              <a:defRPr sz="1800">
-                <a:solidFill>
-                  <a:srgbClr val="222222"/>
-                </a:solidFill>
-              </a:defRPr>
-            </a:pPr>
-            <a:r>
-              <a:t>•  Retrocopies / decidable paralogs: decisive reads don't tie → excluded.</a:t>
-            </a:r>
-          </a:p>
-          <a:p>
-            <a:pPr>
-              <a:spcAft>
-                <a:spcPts val="700"/>
-              </a:spcAft>
-              <a:defRPr sz="1800">
-                <a:solidFill>
-                  <a:srgbClr val="127A6E"/>
-                </a:solidFill>
-              </a:defRPr>
-            </a:pPr>
-            <a:r>
-              <a:t>•  ⚠ At GENOME scale, Alu/repeat bridges DO over-merge (e.g. OCLN/SEPTIN7) — so not 'by construction' universally;</a:t>
-            </a:r>
-          </a:p>
-          <a:p>
-            <a:pPr>
-              <a:spcAft>
-                <a:spcPts val="700"/>
-              </a:spcAft>
-              <a:defRPr sz="1500">
-                <a:solidFill>
-                  <a:srgbClr val="127A6E"/>
-                </a:solidFill>
-              </a:defRPr>
-            </a:pPr>
-            <a:r>
-              <a:t>      –  the production catalog adds a downstream exon-sum homology refine (asm20 id≥0.80/cov≥0.50) to remove them.</a:t>
-            </a:r>
-          </a:p>
-          <a:p>
-            <a:pPr>
-              <a:spcAft>
-                <a:spcPts val="700"/>
-              </a:spcAft>
-              <a:defRPr sz="1500">
-                <a:solidFill>
-                  <a:srgbClr val="222222"/>
-                </a:solidFill>
-              </a:defRPr>
-            </a:pPr>
-            <a:r>
-              <a:t>      –  The one precondition: vertices must be per-transcript loci (the production unit).</a:t>
-            </a:r>
-          </a:p>
-          <a:p>
-            <a:pPr>
-              <a:spcAft>
-                <a:spcPts val="700"/>
-              </a:spcAft>
-              <a:defRPr sz="1500">
-                <a:solidFill>
-                  <a:srgbClr val="222222"/>
-                </a:solidFill>
-              </a:defRPr>
-            </a:pPr>
-            <a:r>
-              <a:t>      –  coarse gene-span vertices reintroduce over-merge — and that bridge is exactly what collapses 59→20</a:t>
-            </a:r>
-          </a:p>
-          <a:p>
-            <a:pPr>
-              <a:spcAft>
-                <a:spcPts val="700"/>
-              </a:spcAft>
-              <a:defRPr sz="1500">
-                <a:solidFill>
-                  <a:srgbClr val="222222"/>
-                </a:solidFill>
-              </a:defRPr>
-            </a:pPr>
-            <a:r>
-              <a:t>      –  when we move to de-novo loci (next slide). So the only knob is vertex resolution, and it is pinned.</a:t>
-            </a:r>
-          </a:p>
-        </p:txBody>
-      </p:sp>
-    </p:spTree>
-  </p:cSld>
-  <p:clrMapOvr>
-    <a:masterClrMapping/>
-  </p:clrMapOvr>
-</p:sld>
-</file>
-
-<file path=ppt/slides/slide11.xml><?xml version="1.0" encoding="utf-8"?>
-<p:sld xmlns:a="http://schemas.openxmlformats.org/drawingml/2006/main" xmlns:p="http://schemas.openxmlformats.org/presentationml/2006/main" xmlns:r="http://schemas.openxmlformats.org/officeDocument/2006/relationships">
-  <p:cSld>
-    <p:spTree>
-      <p:nvGrpSpPr>
-        <p:cNvPr id="1" name=""/>
-        <p:cNvGrpSpPr/>
-        <p:nvPr/>
-      </p:nvGrpSpPr>
-      <p:grpSpPr/>
-      <p:sp>
-        <p:nvSpPr>
-          <p:cNvPr id="2" name="TextBox 1"/>
-          <p:cNvSpPr txBox="1"/>
-          <p:nvPr/>
-        </p:nvSpPr>
-        <p:spPr>
-          <a:xfrm>
-            <a:off x="457200" y="274320"/>
-            <a:ext cx="11247120" cy="822960"/>
-          </a:xfrm>
-          <a:prstGeom prst="rect">
-            <a:avLst/>
-          </a:prstGeom>
-          <a:noFill/>
-        </p:spPr>
-        <p:txBody>
-          <a:bodyPr wrap="none">
-            <a:spAutoFit/>
-          </a:bodyPr>
-          <a:lstStyle/>
-          <a:p>
-            <a:pPr>
-              <a:defRPr sz="2600" b="1">
-                <a:solidFill>
-                  <a:srgbClr val="1F2D5A"/>
-                </a:solidFill>
-              </a:defRPr>
-            </a:pPr>
-            <a:r>
-              <a:t>The thresholds are error-model-MOTIVATED operating points (named, not eliminated)</a:t>
-            </a:r>
-          </a:p>
-        </p:txBody>
-      </p:sp>
-      <p:sp>
-        <p:nvSpPr>
-          <p:cNvPr id="3" name="TextBox 2"/>
-          <p:cNvSpPr txBox="1"/>
-          <p:nvPr/>
-        </p:nvSpPr>
-        <p:spPr>
-          <a:xfrm>
-            <a:off x="548640" y="1280160"/>
-            <a:ext cx="11064240" cy="4937760"/>
-          </a:xfrm>
-          <a:prstGeom prst="rect">
-            <a:avLst/>
-          </a:prstGeom>
-          <a:noFill/>
-        </p:spPr>
-        <p:txBody>
-          <a:bodyPr wrap="square">
-            <a:spAutoFit/>
-          </a:bodyPr>
-          <a:lstStyle/>
-          <a:p>
-            <a:pPr>
-              <a:spcAft>
-                <a:spcPts val="700"/>
-              </a:spcAft>
-              <a:defRPr sz="1800">
-                <a:solidFill>
-                  <a:srgbClr val="1F2D5A"/>
-                </a:solidFill>
-              </a:defRPr>
-            </a:pPr>
-            <a:r>
-              <a:t>•  Δ = 0.005 ≈ the single-read divergence-discrimination RESOLUTION at HiFi error — a motivated scale, not arbitrary.</a:t>
-            </a:r>
-          </a:p>
-          <a:p>
-            <a:pPr>
-              <a:spcAft>
-                <a:spcPts val="700"/>
-              </a:spcAft>
-              <a:defRPr sz="1500">
-                <a:solidFill>
-                  <a:srgbClr val="222222"/>
-                </a:solidFill>
-              </a:defRPr>
-            </a:pPr>
-            <a:r>
-              <a:t>      –  per-read de has SE √(ε/L) ≈ 0.0009; the TIE statistic |de_i − de_j| has SE √(2ε/L) ≈ 0.0013 → ~4σ ≈ 0.005.</a:t>
-            </a:r>
-          </a:p>
-          <a:p>
-            <a:pPr>
-              <a:spcAft>
-                <a:spcPts val="700"/>
-              </a:spcAft>
-              <a:defRPr sz="1500">
-                <a:solidFill>
-                  <a:srgbClr val="127A6E"/>
-                </a:solidFill>
-              </a:defRPr>
-            </a:pPr>
-            <a:r>
-              <a:t>      –  ⚠ BUT it is a knife-edge operating point, NOT 'derived': 0.01 re-admits CNN2, 0.02 re-admits EEF1A1;</a:t>
-            </a:r>
-          </a:p>
-          <a:p>
-            <a:pPr>
-              <a:spcAft>
-                <a:spcPts val="700"/>
-              </a:spcAft>
-              <a:defRPr sz="1500">
-                <a:solidFill>
-                  <a:srgbClr val="127A6E"/>
-                </a:solidFill>
-              </a:defRPr>
-            </a:pPr>
-            <a:r>
-              <a:t>      –  the Δ-sweep 'first error at 0.007' is consistency vs the SAME catalog (circular), not an independent confirmation.</a:t>
-            </a:r>
-          </a:p>
-          <a:p>
-            <a:pPr>
-              <a:spcAft>
-                <a:spcPts val="700"/>
-              </a:spcAft>
-              <a:defRPr sz="1800">
-                <a:solidFill>
-                  <a:srgbClr val="222222"/>
-                </a:solidFill>
-              </a:defRPr>
-            </a:pPr>
-            <a:r>
-              <a:t>•  DE_max = 0.05: loose copy-vs-distinct-gene ceiling.   MIN_READS = 3: minimum-evidence quorum.</a:t>
-            </a:r>
-          </a:p>
-          <a:p>
-            <a:pPr>
-              <a:spcAft>
-                <a:spcPts val="700"/>
-              </a:spcAft>
-              <a:defRPr sz="1800">
-                <a:solidFill>
-                  <a:srgbClr val="222222"/>
-                </a:solidFill>
-              </a:defRPr>
-            </a:pPr>
-            <a:r>
-              <a:t>•  Independent Ensembl Compara: RABL2 (Homininae), MAGEA (Catarrhini) confirmed recent paralogs;</a:t>
-            </a:r>
-          </a:p>
-          <a:p>
-            <a:pPr>
-              <a:spcAft>
-                <a:spcPts val="700"/>
-              </a:spcAft>
-              <a:defRPr sz="1500">
-                <a:solidFill>
-                  <a:srgbClr val="222222"/>
-                </a:solidFill>
-              </a:defRPr>
-            </a:pPr>
-            <a:r>
-              <a:t>      –  APOBEC3 confirms the strict-subset (recent paralog, yet correctly excluded).</a:t>
-            </a:r>
-          </a:p>
-        </p:txBody>
-      </p:sp>
-    </p:spTree>
-  </p:cSld>
-  <p:clrMapOvr>
-    <a:masterClrMapping/>
-  </p:clrMapOvr>
-</p:sld>
-</file>
-
-<file path=ppt/slides/slide12.xml><?xml version="1.0" encoding="utf-8"?>
-<p:sld xmlns:a="http://schemas.openxmlformats.org/drawingml/2006/main" xmlns:p="http://schemas.openxmlformats.org/presentationml/2006/main" xmlns:r="http://schemas.openxmlformats.org/officeDocument/2006/relationships">
-  <p:cSld>
-    <p:spTree>
-      <p:nvGrpSpPr>
-        <p:cNvPr id="1" name=""/>
-        <p:cNvGrpSpPr/>
-        <p:nvPr/>
-      </p:nvGrpSpPr>
-      <p:grpSpPr/>
-      <p:sp>
-        <p:nvSpPr>
-          <p:cNvPr id="2" name="TextBox 1"/>
-          <p:cNvSpPr txBox="1"/>
-          <p:nvPr/>
-        </p:nvSpPr>
-        <p:spPr>
-          <a:xfrm>
-            <a:off x="457200" y="228600"/>
+            <a:off x="457200" y="201168"/>
             <a:ext cx="11247120" cy="731520"/>
           </a:xfrm>
           <a:prstGeom prst="rect">
@@ -3627,14 +3120,14 @@
               </a:defRPr>
             </a:pPr>
             <a:r>
-              <a:t>Genome-wide — stable, sensible, NOT overfit to the panel</a:t>
+              <a:t>What is a multi-copy gene family?</a:t>
             </a:r>
           </a:p>
         </p:txBody>
       </p:sp>
       <p:pic>
         <p:nvPicPr>
-          <p:cNvPr id="3" name="Picture 2" descr="family_def_genomewide_fig.png"/>
+          <p:cNvPr id="3" name="Picture 2" descr="famdef_1_definition.png"/>
           <p:cNvPicPr>
             <a:picLocks noChangeAspect="1"/>
           </p:cNvPicPr>
@@ -3648,8 +3141,8 @@
         </p:blipFill>
         <p:spPr>
           <a:xfrm>
-            <a:off x="470916" y="1051560"/>
-            <a:ext cx="11247120" cy="3339382"/>
+            <a:off x="1578381" y="1051560"/>
+            <a:ext cx="9032189" cy="4937760"/>
           </a:xfrm>
           <a:prstGeom prst="rect">
             <a:avLst/>
@@ -3664,7 +3157,7 @@
         </p:nvSpPr>
         <p:spPr>
           <a:xfrm>
-            <a:off x="548640" y="6126480"/>
+            <a:off x="548640" y="6172200"/>
             <a:ext cx="11064240" cy="548640"/>
           </a:xfrm>
           <a:prstGeom prst="rect">
@@ -3673,7 +3166,7 @@
           <a:noFill/>
         </p:spPr>
         <p:txBody>
-          <a:bodyPr wrap="none">
+          <a:bodyPr wrap="square">
             <a:spAutoFit/>
           </a:bodyPr>
           <a:lstStyle/>
@@ -3686,1014 +3179,7 @@
               </a:defRPr>
             </a:pPr>
             <a:r>
-              <a:t>34k independent gene vertices → 416 families, 57% size-2, 86% co-located; Δ flat to ±7%; production de-novo loci collapse the coarse over-merge bridges 59→20 (worst mega-bridges vanish).</a:t>
-            </a:r>
-          </a:p>
-        </p:txBody>
-      </p:sp>
-    </p:spTree>
-  </p:cSld>
-  <p:clrMapOvr>
-    <a:masterClrMapping/>
-  </p:clrMapOvr>
-</p:sld>
-</file>
-
-<file path=ppt/slides/slide13.xml><?xml version="1.0" encoding="utf-8"?>
-<p:sld xmlns:a="http://schemas.openxmlformats.org/drawingml/2006/main" xmlns:p="http://schemas.openxmlformats.org/presentationml/2006/main" xmlns:r="http://schemas.openxmlformats.org/officeDocument/2006/relationships">
-  <p:cSld>
-    <p:spTree>
-      <p:nvGrpSpPr>
-        <p:cNvPr id="1" name=""/>
-        <p:cNvGrpSpPr/>
-        <p:nvPr/>
-      </p:nvGrpSpPr>
-      <p:grpSpPr/>
-      <p:sp>
-        <p:nvSpPr>
-          <p:cNvPr id="2" name="TextBox 1"/>
-          <p:cNvSpPr txBox="1"/>
-          <p:nvPr/>
-        </p:nvSpPr>
-        <p:spPr>
-          <a:xfrm>
-            <a:off x="457200" y="274320"/>
-            <a:ext cx="11247120" cy="822960"/>
-          </a:xfrm>
-          <a:prstGeom prst="rect">
-            <a:avLst/>
-          </a:prstGeom>
-          <a:noFill/>
-        </p:spPr>
-        <p:txBody>
-          <a:bodyPr wrap="none">
-            <a:spAutoFit/>
-          </a:bodyPr>
-          <a:lstStyle/>
-          <a:p>
-            <a:pPr>
-              <a:defRPr sz="2600" b="1">
-                <a:solidFill>
-                  <a:srgbClr val="1F2D5A"/>
-                </a:solidFill>
-              </a:defRPr>
-            </a:pPr>
-            <a:r>
-              <a:t>Precision / recall vs a DNA-sequence ground truth</a:t>
-            </a:r>
-          </a:p>
-        </p:txBody>
-      </p:sp>
-      <p:sp>
-        <p:nvSpPr>
-          <p:cNvPr id="3" name="TextBox 2"/>
-          <p:cNvSpPr txBox="1"/>
-          <p:nvPr/>
-        </p:nvSpPr>
-        <p:spPr>
-          <a:xfrm>
-            <a:off x="548640" y="1280160"/>
-            <a:ext cx="11064240" cy="4937760"/>
-          </a:xfrm>
-          <a:prstGeom prst="rect">
-            <a:avLst/>
-          </a:prstGeom>
-          <a:noFill/>
-        </p:spPr>
-        <p:txBody>
-          <a:bodyPr wrap="square">
-            <a:spAutoFit/>
-          </a:bodyPr>
-          <a:lstStyle/>
-          <a:p>
-            <a:pPr>
-              <a:spcAft>
-                <a:spcPts val="700"/>
-              </a:spcAft>
-              <a:defRPr sz="1800">
-                <a:solidFill>
-                  <a:srgbClr val="222222"/>
-                </a:solidFill>
-              </a:defRPr>
-            </a:pPr>
-            <a:r>
-              <a:t>•  Independent DNA 'ground truth': all-vs-all cDNA homology over the SAME 34k gene vertices,</a:t>
-            </a:r>
-          </a:p>
-          <a:p>
-            <a:pPr>
-              <a:spcAft>
-                <a:spcPts val="700"/>
-              </a:spcAft>
-              <a:defRPr sz="1500">
-                <a:solidFill>
-                  <a:srgbClr val="222222"/>
-                </a:solidFill>
-              </a:defRPr>
-            </a:pPr>
-            <a:r>
-              <a:t>      –  edge iff identity ≥ 90% AND aligned fraction ≥ 30% (the pinned paralogy bar) → 17,410 paralog edges / 1,460 families. No reads used.</a:t>
-            </a:r>
-          </a:p>
-          <a:p>
-            <a:pPr>
-              <a:spcAft>
-                <a:spcPts val="700"/>
-              </a:spcAft>
-              <a:defRPr sz="1800">
-                <a:solidFill>
-                  <a:srgbClr val="1F2D5A"/>
-                </a:solidFill>
-              </a:defRPr>
-            </a:pPr>
-            <a:r>
-              <a:t>•  Edge-level vs the RNA de-tie graph (2,829 edges):   raw precision = 0.64,   raw recall = 0.10.</a:t>
-            </a:r>
-          </a:p>
-          <a:p>
-            <a:pPr>
-              <a:spcAft>
-                <a:spcPts val="700"/>
-              </a:spcAft>
-              <a:defRPr sz="1500">
-                <a:solidFill>
-                  <a:srgbClr val="222222"/>
-                </a:solidFill>
-              </a:defRPr>
-            </a:pPr>
-            <a:r>
-              <a:t>      –  every number independently re-derived from the raw alignments — 0 discrepancies.</a:t>
-            </a:r>
-          </a:p>
-          <a:p>
-            <a:pPr>
-              <a:spcAft>
-                <a:spcPts val="700"/>
-              </a:spcAft>
-              <a:defRPr sz="1800">
-                <a:solidFill>
-                  <a:srgbClr val="127A6E"/>
-                </a:solidFill>
-              </a:defRPr>
-            </a:pPr>
-            <a:r>
-              <a:t>•  But raw P/R are NOT error rates — both axes are dominated by DEFINITIONAL differences:</a:t>
-            </a:r>
-          </a:p>
-          <a:p>
-            <a:pPr>
-              <a:spcAft>
-                <a:spcPts val="700"/>
-              </a:spcAft>
-              <a:defRPr sz="1500">
-                <a:solidFill>
-                  <a:srgbClr val="222222"/>
-                </a:solidFill>
-              </a:defRPr>
-            </a:pPr>
-            <a:r>
-              <a:t>      –  the two definitions answer different questions, and the DNA bar has its own threshold incoherence.</a:t>
-            </a:r>
-          </a:p>
-        </p:txBody>
-      </p:sp>
-      <p:sp>
-        <p:nvSpPr>
-          <p:cNvPr id="4" name="TextBox 3"/>
-          <p:cNvSpPr txBox="1"/>
-          <p:nvPr/>
-        </p:nvSpPr>
-        <p:spPr>
-          <a:xfrm>
-            <a:off x="548640" y="6263640"/>
-            <a:ext cx="11064240" cy="457200"/>
-          </a:xfrm>
-          <a:prstGeom prst="rect">
-            <a:avLst/>
-          </a:prstGeom>
-          <a:noFill/>
-        </p:spPr>
-        <p:txBody>
-          <a:bodyPr wrap="none">
-            <a:spAutoFit/>
-          </a:bodyPr>
-          <a:lstStyle/>
-          <a:p>
-            <a:pPr>
-              <a:defRPr sz="1100" i="1">
-                <a:solidFill>
-                  <a:srgbClr val="444444"/>
-                </a:solidFill>
-              </a:defRPr>
-            </a:pPr>
-            <a:r>
-              <a:t>DNA truth = minimap2 asm20 all-vs-all of the longest cDNA per gene; same vertices as the RNA graph.</a:t>
-            </a:r>
-          </a:p>
-        </p:txBody>
-      </p:sp>
-    </p:spTree>
-  </p:cSld>
-  <p:clrMapOvr>
-    <a:masterClrMapping/>
-  </p:clrMapOvr>
-</p:sld>
-</file>
-
-<file path=ppt/slides/slide14.xml><?xml version="1.0" encoding="utf-8"?>
-<p:sld xmlns:a="http://schemas.openxmlformats.org/drawingml/2006/main" xmlns:p="http://schemas.openxmlformats.org/presentationml/2006/main" xmlns:r="http://schemas.openxmlformats.org/officeDocument/2006/relationships">
-  <p:cSld>
-    <p:spTree>
-      <p:nvGrpSpPr>
-        <p:cNvPr id="1" name=""/>
-        <p:cNvGrpSpPr/>
-        <p:nvPr/>
-      </p:nvGrpSpPr>
-      <p:grpSpPr/>
-      <p:sp>
-        <p:nvSpPr>
-          <p:cNvPr id="2" name="TextBox 1"/>
-          <p:cNvSpPr txBox="1"/>
-          <p:nvPr/>
-        </p:nvSpPr>
-        <p:spPr>
-          <a:xfrm>
-            <a:off x="457200" y="228600"/>
-            <a:ext cx="11247120" cy="731520"/>
-          </a:xfrm>
-          <a:prstGeom prst="rect">
-            <a:avLst/>
-          </a:prstGeom>
-          <a:noFill/>
-        </p:spPr>
-        <p:txBody>
-          <a:bodyPr wrap="none">
-            <a:spAutoFit/>
-          </a:bodyPr>
-          <a:lstStyle/>
-          <a:p>
-            <a:pPr>
-              <a:defRPr sz="2400" b="1">
-                <a:solidFill>
-                  <a:srgbClr val="1F2D5A"/>
-                </a:solidFill>
-              </a:defRPr>
-            </a:pPr>
-            <a:r>
-              <a:t>What the raw numbers hide — the honest decomposition</a:t>
-            </a:r>
-          </a:p>
-        </p:txBody>
-      </p:sp>
-      <p:pic>
-        <p:nvPicPr>
-          <p:cNvPr id="3" name="Picture 2" descr="family_def_dna_pr_fig.png"/>
-          <p:cNvPicPr>
-            <a:picLocks noChangeAspect="1"/>
-          </p:cNvPicPr>
-          <p:nvPr/>
-        </p:nvPicPr>
-        <p:blipFill>
-          <a:blip r:embed="rId2"/>
-          <a:stretch>
-            <a:fillRect/>
-          </a:stretch>
-        </p:blipFill>
-        <p:spPr>
-          <a:xfrm>
-            <a:off x="470916" y="1051560"/>
-            <a:ext cx="11247120" cy="4295436"/>
-          </a:xfrm>
-          <a:prstGeom prst="rect">
-            <a:avLst/>
-          </a:prstGeom>
-        </p:spPr>
-      </p:pic>
-      <p:sp>
-        <p:nvSpPr>
-          <p:cNvPr id="4" name="TextBox 3"/>
-          <p:cNvSpPr txBox="1"/>
-          <p:nvPr/>
-        </p:nvSpPr>
-        <p:spPr>
-          <a:xfrm>
-            <a:off x="548640" y="6126480"/>
-            <a:ext cx="11064240" cy="548640"/>
-          </a:xfrm>
-          <a:prstGeom prst="rect">
-            <a:avLst/>
-          </a:prstGeom>
-          <a:noFill/>
-        </p:spPr>
-        <p:txBody>
-          <a:bodyPr wrap="none">
-            <a:spAutoFit/>
-          </a:bodyPr>
-          <a:lstStyle/>
-          <a:p>
-            <a:pPr algn="ctr">
-              <a:defRPr sz="1200">
-                <a:solidFill>
-                  <a:srgbClr val="444444"/>
-                </a:solidFill>
-              </a:defRPr>
-            </a:pPr>
-            <a:r>
-              <a:t>(A) 80% of 'missed' DNA paralog pairs are transcriptionally SILENT; of expressed co-mapping pairs the method links 0.66.   (B) no clean coverage cut separates real paralogs (RABL2) from domain-sharers (CREB1~METTL21A) — distributions overlap.</a:t>
-            </a:r>
-          </a:p>
-        </p:txBody>
-      </p:sp>
-    </p:spTree>
-  </p:cSld>
-  <p:clrMapOvr>
-    <a:masterClrMapping/>
-  </p:clrMapOvr>
-</p:sld>
-</file>
-
-<file path=ppt/slides/slide15.xml><?xml version="1.0" encoding="utf-8"?>
-<p:sld xmlns:a="http://schemas.openxmlformats.org/drawingml/2006/main" xmlns:p="http://schemas.openxmlformats.org/presentationml/2006/main" xmlns:r="http://schemas.openxmlformats.org/officeDocument/2006/relationships">
-  <p:cSld>
-    <p:spTree>
-      <p:nvGrpSpPr>
-        <p:cNvPr id="1" name=""/>
-        <p:cNvGrpSpPr/>
-        <p:nvPr/>
-      </p:nvGrpSpPr>
-      <p:grpSpPr/>
-      <p:sp>
-        <p:nvSpPr>
-          <p:cNvPr id="2" name="TextBox 1"/>
-          <p:cNvSpPr txBox="1"/>
-          <p:nvPr/>
-        </p:nvSpPr>
-        <p:spPr>
-          <a:xfrm>
-            <a:off x="457200" y="274320"/>
-            <a:ext cx="11247120" cy="822960"/>
-          </a:xfrm>
-          <a:prstGeom prst="rect">
-            <a:avLst/>
-          </a:prstGeom>
-          <a:noFill/>
-        </p:spPr>
-        <p:txBody>
-          <a:bodyPr wrap="none">
-            <a:spAutoFit/>
-          </a:bodyPr>
-          <a:lstStyle/>
-          <a:p>
-            <a:pPr>
-              <a:defRPr sz="2600" b="1">
-                <a:solidFill>
-                  <a:srgbClr val="1F2D5A"/>
-                </a:solidFill>
-              </a:defRPr>
-            </a:pPr>
-            <a:r>
-              <a:t>The honest read — recall and precision</a:t>
-            </a:r>
-          </a:p>
-        </p:txBody>
-      </p:sp>
-      <p:sp>
-        <p:nvSpPr>
-          <p:cNvPr id="3" name="TextBox 2"/>
-          <p:cNvSpPr txBox="1"/>
-          <p:nvPr/>
-        </p:nvSpPr>
-        <p:spPr>
-          <a:xfrm>
-            <a:off x="548640" y="1280160"/>
-            <a:ext cx="11064240" cy="4937760"/>
-          </a:xfrm>
-          <a:prstGeom prst="rect">
-            <a:avLst/>
-          </a:prstGeom>
-          <a:noFill/>
-        </p:spPr>
-        <p:txBody>
-          <a:bodyPr wrap="square">
-            <a:spAutoFit/>
-          </a:bodyPr>
-          <a:lstStyle/>
-          <a:p>
-            <a:pPr>
-              <a:spcAft>
-                <a:spcPts val="700"/>
-              </a:spcAft>
-              <a:defRPr sz="1800">
-                <a:solidFill>
-                  <a:srgbClr val="1F2D5A"/>
-                </a:solidFill>
-              </a:defRPr>
-            </a:pPr>
-            <a:r>
-              <a:t>•  RECALL: 80% of 'missed' DNA paralog pairs are transcriptionally SILENT (≥1 copy unexpressed → invisible to RNA).</a:t>
-            </a:r>
-          </a:p>
-          <a:p>
-            <a:pPr>
-              <a:spcAft>
-                <a:spcPts val="700"/>
-              </a:spcAft>
-              <a:defRPr sz="1500">
-                <a:solidFill>
-                  <a:srgbClr val="222222"/>
-                </a:solidFill>
-              </a:defRPr>
-            </a:pPr>
-            <a:r>
-              <a:t>      –  of expressed, co-mapping paralog pairs the method links 0.66 (the honest single figure);</a:t>
-            </a:r>
-          </a:p>
-          <a:p>
-            <a:pPr>
-              <a:spcAft>
-                <a:spcPts val="700"/>
-              </a:spcAft>
-              <a:defRPr sz="1500">
-                <a:solidFill>
-                  <a:srgbClr val="222222"/>
-                </a:solidFill>
-              </a:defRPr>
-            </a:pPr>
-            <a:r>
-              <a:t>      –  residual = 423 sub-quorum (1–2 tied reads) + 524 resolvable (reads place decisively).</a:t>
-            </a:r>
-          </a:p>
-          <a:p>
-            <a:pPr>
-              <a:spcAft>
-                <a:spcPts val="700"/>
-              </a:spcAft>
-              <a:defRPr sz="1800">
-                <a:solidFill>
-                  <a:srgbClr val="1F2D5A"/>
-                </a:solidFill>
-              </a:defRPr>
-            </a:pPr>
-            <a:r>
-              <a:t>•  PRECISION: 21% of nominal 'false' edges (212) are real paralogs JUST under the arbitrary 90%/30% bar</a:t>
-            </a:r>
-          </a:p>
-          <a:p>
-            <a:pPr>
-              <a:spcAft>
-                <a:spcPts val="700"/>
-              </a:spcAft>
-              <a:defRPr sz="1500">
-                <a:solidFill>
-                  <a:srgbClr val="222222"/>
-                </a:solidFill>
-              </a:defRPr>
-            </a:pPr>
-            <a:r>
-              <a:t>      –  (e.g. TBC1D1~LOC at id 0.8975, 293 reads) → DNA-truth under-detection; effective precision ≥ 0.72.</a:t>
-            </a:r>
-          </a:p>
-          <a:p>
-            <a:pPr>
-              <a:spcAft>
-                <a:spcPts val="700"/>
-              </a:spcAft>
-              <a:defRPr sz="1800">
-                <a:solidFill>
-                  <a:srgbClr val="D96B27"/>
-                </a:solidFill>
-              </a:defRPr>
-            </a:pPr>
-            <a:r>
-              <a:t>•  'Family' = read-indistinguishable locus pair  ⊋  paralogy: high-evidence cross-chrom edges (OCLN~SEPTIN7, 3,369 reads)</a:t>
-            </a:r>
-          </a:p>
-          <a:p>
-            <a:pPr>
-              <a:spcAft>
-                <a:spcPts val="700"/>
-              </a:spcAft>
-              <a:defRPr sz="1500">
-                <a:solidFill>
-                  <a:srgbClr val="222222"/>
-                </a:solidFill>
-              </a:defRPr>
-            </a:pPr>
-            <a:r>
-              <a:t>      –  are retrocopies / pseudogenes / read-through fusions — which the cDNA-vs-cDNA truth ALSO cannot represent (mutual blind spot).</a:t>
-            </a:r>
-          </a:p>
-        </p:txBody>
-      </p:sp>
-    </p:spTree>
-  </p:cSld>
-  <p:clrMapOvr>
-    <a:masterClrMapping/>
-  </p:clrMapOvr>
-</p:sld>
-</file>
-
-<file path=ppt/slides/slide16.xml><?xml version="1.0" encoding="utf-8"?>
-<p:sld xmlns:a="http://schemas.openxmlformats.org/drawingml/2006/main" xmlns:p="http://schemas.openxmlformats.org/presentationml/2006/main" xmlns:r="http://schemas.openxmlformats.org/officeDocument/2006/relationships">
-  <p:cSld>
-    <p:spTree>
-      <p:nvGrpSpPr>
-        <p:cNvPr id="1" name=""/>
-        <p:cNvGrpSpPr/>
-        <p:nvPr/>
-      </p:nvGrpSpPr>
-      <p:grpSpPr/>
-      <p:sp>
-        <p:nvSpPr>
-          <p:cNvPr id="2" name="TextBox 1"/>
-          <p:cNvSpPr txBox="1"/>
-          <p:nvPr/>
-        </p:nvSpPr>
-        <p:spPr>
-          <a:xfrm>
-            <a:off x="457200" y="274320"/>
-            <a:ext cx="11247120" cy="822960"/>
-          </a:xfrm>
-          <a:prstGeom prst="rect">
-            <a:avLst/>
-          </a:prstGeom>
-          <a:noFill/>
-        </p:spPr>
-        <p:txBody>
-          <a:bodyPr wrap="none">
-            <a:spAutoFit/>
-          </a:bodyPr>
-          <a:lstStyle/>
-          <a:p>
-            <a:pPr>
-              <a:defRPr sz="2600" b="1">
-                <a:solidFill>
-                  <a:srgbClr val="1F2D5A"/>
-                </a:solidFill>
-              </a:defRPr>
-            </a:pPr>
-            <a:r>
-              <a:t>Orthogonal, not nested — and the one clean win</a:t>
-            </a:r>
-          </a:p>
-        </p:txBody>
-      </p:sp>
-      <p:sp>
-        <p:nvSpPr>
-          <p:cNvPr id="3" name="TextBox 2"/>
-          <p:cNvSpPr txBox="1"/>
-          <p:nvPr/>
-        </p:nvSpPr>
-        <p:spPr>
-          <a:xfrm>
-            <a:off x="548640" y="1280160"/>
-            <a:ext cx="11064240" cy="4937760"/>
-          </a:xfrm>
-          <a:prstGeom prst="rect">
-            <a:avLst/>
-          </a:prstGeom>
-          <a:noFill/>
-        </p:spPr>
-        <p:txBody>
-          <a:bodyPr wrap="square">
-            <a:spAutoFit/>
-          </a:bodyPr>
-          <a:lstStyle/>
-          <a:p>
-            <a:pPr>
-              <a:spcAft>
-                <a:spcPts val="700"/>
-              </a:spcAft>
-              <a:defRPr sz="1800">
-                <a:solidFill>
-                  <a:srgbClr val="222222"/>
-                </a:solidFill>
-              </a:defRPr>
-            </a:pPr>
-            <a:r>
-              <a:t>•  The two graphs CROSS: 830 whole-gene paralog pairs the RNA graph misses vs 1,130 RNA edges that are not whole-gene paralogs.</a:t>
-            </a:r>
-          </a:p>
-          <a:p>
-            <a:pPr>
-              <a:spcAft>
-                <a:spcPts val="700"/>
-              </a:spcAft>
-              <a:defRPr sz="1500">
-                <a:solidFill>
-                  <a:srgbClr val="127A6E"/>
-                </a:solidFill>
-              </a:defRPr>
-            </a:pPr>
-            <a:r>
-              <a:t>      –  → the read-conflict graph is NOT a proxy for a static coverage threshold; it conditions on transcribed, co-mapping evidence.</a:t>
-            </a:r>
-          </a:p>
-          <a:p>
-            <a:pPr>
-              <a:spcAft>
-                <a:spcPts val="700"/>
-              </a:spcAft>
-              <a:defRPr sz="1800">
-                <a:solidFill>
-                  <a:srgbClr val="222222"/>
-                </a:solidFill>
-              </a:defRPr>
-            </a:pPr>
-            <a:r>
-              <a:t>•  No single coverage cut separates cleanly: RNA-confirmed reciprocal-cov median 0.75 vs DNA-only 0.27 (overlapping).</a:t>
-            </a:r>
-          </a:p>
-          <a:p>
-            <a:pPr>
-              <a:spcAft>
-                <a:spcPts val="700"/>
-              </a:spcAft>
-              <a:defRPr sz="1500">
-                <a:solidFill>
-                  <a:srgbClr val="222222"/>
-                </a:solidFill>
-              </a:defRPr>
-            </a:pPr>
-            <a:r>
-              <a:t>      –  the reciprocal bar DROPS RABL2 (real, 0.34) yet KEEPS CREB1~METTL21A (domain-sharer, 0.54).</a:t>
-            </a:r>
-          </a:p>
-          <a:p>
-            <a:pPr>
-              <a:spcAft>
-                <a:spcPts val="700"/>
-              </a:spcAft>
-              <a:defRPr sz="1800">
-                <a:solidFill>
-                  <a:srgbClr val="1F2D5A"/>
-                </a:solidFill>
-              </a:defRPr>
-            </a:pPr>
-            <a:r>
-              <a:t>•  THE CLEAN WIN — domain-sharers: 5/5 nested/adjacent genes sharing ONE domain at mapq 0,</a:t>
-            </a:r>
-          </a:p>
-          <a:p>
-            <a:pPr>
-              <a:spcAft>
-                <a:spcPts val="700"/>
-              </a:spcAft>
-              <a:defRPr sz="1500">
-                <a:solidFill>
-                  <a:srgbClr val="1F2D5A"/>
-                </a:solidFill>
-              </a:defRPr>
-            </a:pPr>
-            <a:r>
-              <a:t>      –  over-called as families by ANY DNA homology bar, correctly excluded by read best-overlap attribution.</a:t>
-            </a:r>
-          </a:p>
-          <a:p>
-            <a:pPr>
-              <a:spcAft>
-                <a:spcPts val="700"/>
-              </a:spcAft>
-              <a:defRPr sz="1800">
-                <a:solidFill>
-                  <a:srgbClr val="127A6E"/>
-                </a:solidFill>
-              </a:defRPr>
-            </a:pPr>
-            <a:r>
-              <a:t>•  Bottom line: a P/R number exists, but it measures definitional overlap — read-confusability is an orthogonal, expression-conditioned axis.</a:t>
-            </a:r>
-          </a:p>
-        </p:txBody>
-      </p:sp>
-    </p:spTree>
-  </p:cSld>
-  <p:clrMapOvr>
-    <a:masterClrMapping/>
-  </p:clrMapOvr>
-</p:sld>
-</file>
-
-<file path=ppt/slides/slide17.xml><?xml version="1.0" encoding="utf-8"?>
-<p:sld xmlns:a="http://schemas.openxmlformats.org/drawingml/2006/main" xmlns:p="http://schemas.openxmlformats.org/presentationml/2006/main" xmlns:r="http://schemas.openxmlformats.org/officeDocument/2006/relationships">
-  <p:cSld>
-    <p:spTree>
-      <p:nvGrpSpPr>
-        <p:cNvPr id="1" name=""/>
-        <p:cNvGrpSpPr/>
-        <p:nvPr/>
-      </p:nvGrpSpPr>
-      <p:grpSpPr/>
-      <p:sp>
-        <p:nvSpPr>
-          <p:cNvPr id="2" name="TextBox 1"/>
-          <p:cNvSpPr txBox="1"/>
-          <p:nvPr/>
-        </p:nvSpPr>
-        <p:spPr>
-          <a:xfrm>
-            <a:off x="457200" y="274320"/>
-            <a:ext cx="11247120" cy="822960"/>
-          </a:xfrm>
-          <a:prstGeom prst="rect">
-            <a:avLst/>
-          </a:prstGeom>
-          <a:noFill/>
-        </p:spPr>
-        <p:txBody>
-          <a:bodyPr wrap="none">
-            <a:spAutoFit/>
-          </a:bodyPr>
-          <a:lstStyle/>
-          <a:p>
-            <a:pPr>
-              <a:defRPr sz="2600" b="1">
-                <a:solidFill>
-                  <a:srgbClr val="1F2D5A"/>
-                </a:solidFill>
-              </a:defRPr>
-            </a:pPr>
-            <a:r>
-              <a:t>Honest limits (disclosed up front)</a:t>
-            </a:r>
-          </a:p>
-        </p:txBody>
-      </p:sp>
-      <p:sp>
-        <p:nvSpPr>
-          <p:cNvPr id="3" name="TextBox 2"/>
-          <p:cNvSpPr txBox="1"/>
-          <p:nvPr/>
-        </p:nvSpPr>
-        <p:spPr>
-          <a:xfrm>
-            <a:off x="548640" y="1280160"/>
-            <a:ext cx="11064240" cy="4937760"/>
-          </a:xfrm>
-          <a:prstGeom prst="rect">
-            <a:avLst/>
-          </a:prstGeom>
-          <a:noFill/>
-        </p:spPr>
-        <p:txBody>
-          <a:bodyPr wrap="square">
-            <a:spAutoFit/>
-          </a:bodyPr>
-          <a:lstStyle/>
-          <a:p>
-            <a:pPr>
-              <a:spcAft>
-                <a:spcPts val="700"/>
-              </a:spcAft>
-              <a:defRPr sz="1800">
-                <a:solidFill>
-                  <a:srgbClr val="D96B27"/>
-                </a:solidFill>
-              </a:defRPr>
-            </a:pPr>
-            <a:r>
-              <a:t>•  FN=0 holds for ≤6-copy families: minimap2's default secondary cap (N=5) fragments LARGER arrays.</a:t>
-            </a:r>
-          </a:p>
-          <a:p>
-            <a:pPr>
-              <a:spcAft>
-                <a:spcPts val="700"/>
-              </a:spcAft>
-              <a:defRPr sz="1500">
-                <a:solidFill>
-                  <a:srgbClr val="222222"/>
-                </a:solidFill>
-              </a:defRPr>
-            </a:pPr>
-            <a:r>
-              <a:t>      –  MEASURED fix: uncapped re-align (−N 50 −p 0.1) heals a ≥12-copy chr23 array (core 5→11) at 0 FP.</a:t>
-            </a:r>
-          </a:p>
-          <a:p>
-            <a:pPr>
-              <a:spcAft>
-                <a:spcPts val="700"/>
-              </a:spcAft>
-              <a:defRPr sz="1800">
-                <a:solidFill>
-                  <a:srgbClr val="222222"/>
-                </a:solidFill>
-              </a:defRPr>
-            </a:pPr>
-            <a:r>
-              <a:t>•  The panel Δ-plateau was empirically confirmed against 3 resolvable decoys (could be tightened genome-wide).</a:t>
-            </a:r>
-          </a:p>
-          <a:p>
-            <a:pPr>
-              <a:spcAft>
-                <a:spcPts val="700"/>
-              </a:spcAft>
-              <a:defRPr sz="1800">
-                <a:solidFill>
-                  <a:srgbClr val="222222"/>
-                </a:solidFill>
-              </a:defRPr>
-            </a:pPr>
-            <a:r>
-              <a:t>•  DE_max set conservatively, not swept for its own plateau.</a:t>
-            </a:r>
-          </a:p>
-          <a:p>
-            <a:pPr>
-              <a:spcAft>
-                <a:spcPts val="700"/>
-              </a:spcAft>
-              <a:defRPr sz="1800">
-                <a:solidFill>
-                  <a:srgbClr val="222222"/>
-                </a:solidFill>
-              </a:defRPr>
-            </a:pPr>
-            <a:r>
-              <a:t>•  Genome-wide families are dominated by uncharacterized LOC arrays (no orthology DB) → co-location is the proxy.</a:t>
-            </a:r>
-          </a:p>
-          <a:p>
-            <a:pPr>
-              <a:spcAft>
-                <a:spcPts val="700"/>
-              </a:spcAft>
-              <a:defRPr sz="1800">
-                <a:solidFill>
-                  <a:srgbClr val="222222"/>
-                </a:solidFill>
-              </a:defRPr>
-            </a:pPr>
-            <a:r>
-              <a:t>•  ~20 residual cross-chrom families at production resolution = genuine dispersed retrocopies (correct positives).</a:t>
-            </a:r>
-          </a:p>
-          <a:p>
-            <a:pPr>
-              <a:spcAft>
-                <a:spcPts val="700"/>
-              </a:spcAft>
-              <a:defRPr sz="1800">
-                <a:solidFill>
-                  <a:srgbClr val="222222"/>
-                </a:solidFill>
-              </a:defRPr>
-            </a:pPr>
-            <a:r>
-              <a:t>•  RABL2's recovery is quorum-carried (recent-paralog regime: MIN_READS, not a per-read tie).</a:t>
-            </a:r>
-          </a:p>
-        </p:txBody>
-      </p:sp>
-    </p:spTree>
-  </p:cSld>
-  <p:clrMapOvr>
-    <a:masterClrMapping/>
-  </p:clrMapOvr>
-</p:sld>
-</file>
-
-<file path=ppt/slides/slide18.xml><?xml version="1.0" encoding="utf-8"?>
-<p:sld xmlns:a="http://schemas.openxmlformats.org/drawingml/2006/main" xmlns:p="http://schemas.openxmlformats.org/presentationml/2006/main" xmlns:r="http://schemas.openxmlformats.org/officeDocument/2006/relationships">
-  <p:cSld>
-    <p:spTree>
-      <p:nvGrpSpPr>
-        <p:cNvPr id="1" name=""/>
-        <p:cNvGrpSpPr/>
-        <p:nvPr/>
-      </p:nvGrpSpPr>
-      <p:grpSpPr/>
-      <p:sp>
-        <p:nvSpPr>
-          <p:cNvPr id="2" name="TextBox 1"/>
-          <p:cNvSpPr txBox="1"/>
-          <p:nvPr/>
-        </p:nvSpPr>
-        <p:spPr>
-          <a:xfrm>
-            <a:off x="457200" y="274320"/>
-            <a:ext cx="11247120" cy="822960"/>
-          </a:xfrm>
-          <a:prstGeom prst="rect">
-            <a:avLst/>
-          </a:prstGeom>
-          <a:noFill/>
-        </p:spPr>
-        <p:txBody>
-          <a:bodyPr wrap="none">
-            <a:spAutoFit/>
-          </a:bodyPr>
-          <a:lstStyle/>
-          <a:p>
-            <a:pPr>
-              <a:defRPr sz="2600" b="1">
-                <a:solidFill>
-                  <a:srgbClr val="1F2D5A"/>
-                </a:solidFill>
-              </a:defRPr>
-            </a:pPr>
-            <a:r>
-              <a:t>Summary — a relational, RNA-derived family definition</a:t>
-            </a:r>
-          </a:p>
-        </p:txBody>
-      </p:sp>
-      <p:sp>
-        <p:nvSpPr>
-          <p:cNvPr id="3" name="TextBox 2"/>
-          <p:cNvSpPr txBox="1"/>
-          <p:nvPr/>
-        </p:nvSpPr>
-        <p:spPr>
-          <a:xfrm>
-            <a:off x="548640" y="1280160"/>
-            <a:ext cx="11064240" cy="4937760"/>
-          </a:xfrm>
-          <a:prstGeom prst="rect">
-            <a:avLst/>
-          </a:prstGeom>
-          <a:noFill/>
-        </p:spPr>
-        <p:txBody>
-          <a:bodyPr wrap="square">
-            <a:spAutoFit/>
-          </a:bodyPr>
-          <a:lstStyle/>
-          <a:p>
-            <a:pPr>
-              <a:spcAft>
-                <a:spcPts val="700"/>
-              </a:spcAft>
-              <a:defRPr sz="1800">
-                <a:solidFill>
-                  <a:srgbClr val="1F2D5A"/>
-                </a:solidFill>
-              </a:defRPr>
-            </a:pPr>
-            <a:r>
-              <a:t>•  Family = connected component of the read-conflict graph  =  recent-paralogy ∩ read-confusability.</a:t>
-            </a:r>
-          </a:p>
-          <a:p>
-            <a:pPr>
-              <a:spcAft>
-                <a:spcPts val="700"/>
-              </a:spcAft>
-              <a:defRPr sz="1800">
-                <a:solidFill>
-                  <a:srgbClr val="222222"/>
-                </a:solidFill>
-              </a:defRPr>
-            </a:pPr>
-            <a:r>
-              <a:t>•  No ABSOLUTE-similarity bar — a relational tie at the HiFi error-model resolution (with a small tuned tolerance Δ).</a:t>
-            </a:r>
-          </a:p>
-          <a:p>
-            <a:pPr>
-              <a:spcAft>
-                <a:spcPts val="700"/>
-              </a:spcAft>
-              <a:defRPr sz="1800">
-                <a:solidFill>
-                  <a:srgbClr val="222222"/>
-                </a:solidFill>
-              </a:defRPr>
-            </a:pPr>
-            <a:r>
-              <a:t>•  Three structural robustnesses on the panel (domain-sharer · over-split · retrocopy); homology refine guards scale.</a:t>
-            </a:r>
-          </a:p>
-          <a:p>
-            <a:pPr>
-              <a:spcAft>
-                <a:spcPts val="700"/>
-              </a:spcAft>
-              <a:defRPr sz="1800">
-                <a:solidFill>
-                  <a:srgbClr val="127A6E"/>
-                </a:solidFill>
-              </a:defRPr>
-            </a:pPr>
-            <a:r>
-              <a:t>•  TP=7  TN=10  FP=0  FN=0  on the panel; genome-wide stable and de-novo-clean.</a:t>
-            </a:r>
-          </a:p>
-          <a:p>
-            <a:pPr>
-              <a:spcAft>
-                <a:spcPts val="700"/>
-              </a:spcAft>
-              <a:defRPr sz="1800">
-                <a:solidFill>
-                  <a:srgbClr val="127A6E"/>
-                </a:solidFill>
-              </a:defRPr>
-            </a:pPr>
-            <a:r>
-              <a:t>•  It is the exact unit the read-to-copy assignment problem operates on.</a:t>
+              <a:t>A family is ≥2 distinct genomic loci carrying homologous, expressed copies of one gene. Copies are different loci; isoforms are different transcripts from the same locus.</a:t>
             </a:r>
           </a:p>
         </p:txBody>
@@ -4724,8 +3210,8 @@
         </p:nvSpPr>
         <p:spPr>
           <a:xfrm>
-            <a:off x="457200" y="274320"/>
-            <a:ext cx="11247120" cy="822960"/>
+            <a:off x="457200" y="201168"/>
+            <a:ext cx="11247120" cy="731520"/>
           </a:xfrm>
           <a:prstGeom prst="rect">
             <a:avLst/>
@@ -4739,28 +3225,52 @@
           <a:lstStyle/>
           <a:p>
             <a:pPr>
-              <a:defRPr sz="2600" b="1">
+              <a:defRPr sz="2400" b="1">
                 <a:solidFill>
                   <a:srgbClr val="1F2D5A"/>
                 </a:solidFill>
               </a:defRPr>
             </a:pPr>
             <a:r>
-              <a:t>The question</a:t>
-            </a:r>
-          </a:p>
-        </p:txBody>
-      </p:sp>
-      <p:sp>
-        <p:nvSpPr>
-          <p:cNvPr id="3" name="TextBox 2"/>
+              <a:t>Birdseye view: a real family as a quasi-clique</a:t>
+            </a:r>
+          </a:p>
+        </p:txBody>
+      </p:sp>
+      <p:pic>
+        <p:nvPicPr>
+          <p:cNvPr id="3" name="Picture 2" descr="famdef_2_birdseye.png"/>
+          <p:cNvPicPr>
+            <a:picLocks noChangeAspect="1"/>
+          </p:cNvPicPr>
+          <p:nvPr/>
+        </p:nvPicPr>
+        <p:blipFill>
+          <a:blip r:embed="rId2"/>
+          <a:stretch>
+            <a:fillRect/>
+          </a:stretch>
+        </p:blipFill>
+        <p:spPr>
+          <a:xfrm>
+            <a:off x="756532" y="1051560"/>
+            <a:ext cx="10675888" cy="4937760"/>
+          </a:xfrm>
+          <a:prstGeom prst="rect">
+            <a:avLst/>
+          </a:prstGeom>
+        </p:spPr>
+      </p:pic>
+      <p:sp>
+        <p:nvSpPr>
+          <p:cNvPr id="4" name="TextBox 3"/>
           <p:cNvSpPr txBox="1"/>
           <p:nvPr/>
         </p:nvSpPr>
         <p:spPr>
           <a:xfrm>
-            <a:off x="548640" y="1280160"/>
-            <a:ext cx="11064240" cy="4937760"/>
+            <a:off x="548640" y="6172200"/>
+            <a:ext cx="11064240" cy="548640"/>
           </a:xfrm>
           <a:prstGeom prst="rect">
             <a:avLst/>
@@ -4773,93 +3283,15 @@
           </a:bodyPr>
           <a:lstStyle/>
           <a:p>
-            <a:pPr>
-              <a:spcAft>
-                <a:spcPts val="700"/>
-              </a:spcAft>
-              <a:defRPr sz="1800">
+            <a:pPr algn="ctr">
+              <a:defRPr sz="1200">
                 <a:solidFill>
-                  <a:srgbClr val="222222"/>
+                  <a:srgbClr val="444444"/>
                 </a:solidFill>
               </a:defRPr>
             </a:pPr>
             <a:r>
-              <a:t>•  What is a 'gene family' — for the copy-assignment problem?</a:t>
-            </a:r>
-          </a:p>
-          <a:p>
-            <a:pPr>
-              <a:spcAft>
-                <a:spcPts val="700"/>
-              </a:spcAft>
-              <a:defRPr sz="1500">
-                <a:solidFill>
-                  <a:srgbClr val="222222"/>
-                </a:solidFill>
-              </a:defRPr>
-            </a:pPr>
-            <a:r>
-              <a:t>      –  The biological definition (sequence similarity / phylogeny) needs the genome or protein —</a:t>
-            </a:r>
-          </a:p>
-          <a:p>
-            <a:pPr>
-              <a:spcAft>
-                <a:spcPts val="700"/>
-              </a:spcAft>
-              <a:defRPr sz="1500">
-                <a:solidFill>
-                  <a:srgbClr val="222222"/>
-                </a:solidFill>
-              </a:defRPr>
-            </a:pPr>
-            <a:r>
-              <a:t>      –  not derivable from RNA, and circular if used to DETECT families from reads.</a:t>
-            </a:r>
-          </a:p>
-          <a:p>
-            <a:pPr>
-              <a:spcAft>
-                <a:spcPts val="700"/>
-              </a:spcAft>
-              <a:defRPr sz="1800">
-                <a:solidFill>
-                  <a:srgbClr val="222222"/>
-                </a:solidFill>
-              </a:defRPr>
-            </a:pPr>
-            <a:r>
-              <a:t>•  The copy-assignment problem operates on a different unit:</a:t>
-            </a:r>
-          </a:p>
-          <a:p>
-            <a:pPr>
-              <a:spcAft>
-                <a:spcPts val="700"/>
-              </a:spcAft>
-              <a:defRPr sz="1500">
-                <a:solidFill>
-                  <a:srgbClr val="222222"/>
-                </a:solidFill>
-              </a:defRPr>
-            </a:pPr>
-            <a:r>
-              <a:t>      –  the set of loci among which the READS are genuinely confused (multimapping).</a:t>
-            </a:r>
-          </a:p>
-          <a:p>
-            <a:pPr>
-              <a:spcAft>
-                <a:spcPts val="700"/>
-              </a:spcAft>
-              <a:defRPr sz="1800">
-                <a:solidFill>
-                  <a:srgbClr val="127A6E"/>
-                </a:solidFill>
-              </a:defRPr>
-            </a:pPr>
-            <a:r>
-              <a:t>•  Goal: a formal, RNA-derived definition with an honest false-positive / false-negative ledger.</a:t>
+              <a:t>Family 45 (LOC101124778) has two copies on gorilla NC_073224.2. The homology graph is a γ-quasi-clique: not every pair needs an edge, but the group is cohesive enough to be one family.</a:t>
             </a:r>
           </a:p>
         </p:txBody>
@@ -4890,736 +3322,7 @@
         </p:nvSpPr>
         <p:spPr>
           <a:xfrm>
-            <a:off x="457200" y="274320"/>
-            <a:ext cx="11247120" cy="822960"/>
-          </a:xfrm>
-          <a:prstGeom prst="rect">
-            <a:avLst/>
-          </a:prstGeom>
-          <a:noFill/>
-        </p:spPr>
-        <p:txBody>
-          <a:bodyPr wrap="none">
-            <a:spAutoFit/>
-          </a:bodyPr>
-          <a:lstStyle/>
-          <a:p>
-            <a:pPr>
-              <a:defRPr sz="2600" b="1">
-                <a:solidFill>
-                  <a:srgbClr val="1F2D5A"/>
-                </a:solidFill>
-              </a:defRPr>
-            </a:pPr>
-            <a:r>
-              <a:t>Key idea: multimapping reads are shared evidence, not noise</a:t>
-            </a:r>
-          </a:p>
-        </p:txBody>
-      </p:sp>
-      <p:sp>
-        <p:nvSpPr>
-          <p:cNvPr id="3" name="TextBox 2"/>
-          <p:cNvSpPr txBox="1"/>
-          <p:nvPr/>
-        </p:nvSpPr>
-        <p:spPr>
-          <a:xfrm>
-            <a:off x="548640" y="1280160"/>
-            <a:ext cx="11064240" cy="4937760"/>
-          </a:xfrm>
-          <a:prstGeom prst="rect">
-            <a:avLst/>
-          </a:prstGeom>
-          <a:noFill/>
-        </p:spPr>
-        <p:txBody>
-          <a:bodyPr wrap="square">
-            <a:spAutoFit/>
-          </a:bodyPr>
-          <a:lstStyle/>
-          <a:p>
-            <a:pPr>
-              <a:spcAft>
-                <a:spcPts val="700"/>
-              </a:spcAft>
-              <a:defRPr sz="1800">
-                <a:solidFill>
-                  <a:srgbClr val="222222"/>
-                </a:solidFill>
-              </a:defRPr>
-            </a:pPr>
-            <a:r>
-              <a:t>•  A read that maps equally well to two loci = a genuine alternative placement</a:t>
-            </a:r>
-          </a:p>
-          <a:p>
-            <a:pPr>
-              <a:spcAft>
-                <a:spcPts val="700"/>
-              </a:spcAft>
-              <a:defRPr sz="1500">
-                <a:solidFill>
-                  <a:srgbClr val="222222"/>
-                </a:solidFill>
-              </a:defRPr>
-            </a:pPr>
-            <a:r>
-              <a:t>      –  (the multimapping conflict — Canzar's conflict graph).</a:t>
-            </a:r>
-          </a:p>
-          <a:p>
-            <a:pPr>
-              <a:spcAft>
-                <a:spcPts val="700"/>
-              </a:spcAft>
-              <a:defRPr sz="1800">
-                <a:solidFill>
-                  <a:srgbClr val="1F2D5A"/>
-                </a:solidFill>
-              </a:defRPr>
-            </a:pPr>
-            <a:r>
-              <a:t>•  Two loci are in the same family  ⇔  reads cross-map between them at TIED divergence.</a:t>
-            </a:r>
-          </a:p>
-          <a:p>
-            <a:pPr>
-              <a:spcAft>
-                <a:spcPts val="700"/>
-              </a:spcAft>
-              <a:defRPr sz="1800">
-                <a:solidFill>
-                  <a:srgbClr val="1F2D5A"/>
-                </a:solidFill>
-              </a:defRPr>
-            </a:pPr>
-            <a:r>
-              <a:t>•  A family = a connected component of the read-conflict graph.</a:t>
-            </a:r>
-          </a:p>
-          <a:p>
-            <a:pPr>
-              <a:spcAft>
-                <a:spcPts val="700"/>
-              </a:spcAft>
-              <a:defRPr sz="1800">
-                <a:solidFill>
-                  <a:srgbClr val="127A6E"/>
-                </a:solidFill>
-              </a:defRPr>
-            </a:pPr>
-            <a:r>
-              <a:t>•  This is exactly the unit on which read-to-copy assignment must be solved.</a:t>
-            </a:r>
-          </a:p>
-        </p:txBody>
-      </p:sp>
-    </p:spTree>
-  </p:cSld>
-  <p:clrMapOvr>
-    <a:masterClrMapping/>
-  </p:clrMapOvr>
-</p:sld>
-</file>
-
-<file path=ppt/slides/slide4.xml><?xml version="1.0" encoding="utf-8"?>
-<p:sld xmlns:a="http://schemas.openxmlformats.org/drawingml/2006/main" xmlns:p="http://schemas.openxmlformats.org/presentationml/2006/main" xmlns:r="http://schemas.openxmlformats.org/officeDocument/2006/relationships">
-  <p:cSld>
-    <p:spTree>
-      <p:nvGrpSpPr>
-        <p:cNvPr id="1" name=""/>
-        <p:cNvGrpSpPr/>
-        <p:nvPr/>
-      </p:nvGrpSpPr>
-      <p:grpSpPr/>
-      <p:sp>
-        <p:nvSpPr>
-          <p:cNvPr id="2" name="TextBox 1"/>
-          <p:cNvSpPr txBox="1"/>
-          <p:nvPr/>
-        </p:nvSpPr>
-        <p:spPr>
-          <a:xfrm>
-            <a:off x="457200" y="274320"/>
-            <a:ext cx="11247120" cy="822960"/>
-          </a:xfrm>
-          <a:prstGeom prst="rect">
-            <a:avLst/>
-          </a:prstGeom>
-          <a:noFill/>
-        </p:spPr>
-        <p:txBody>
-          <a:bodyPr wrap="none">
-            <a:spAutoFit/>
-          </a:bodyPr>
-          <a:lstStyle/>
-          <a:p>
-            <a:pPr>
-              <a:defRPr sz="2600" b="1">
-                <a:solidFill>
-                  <a:srgbClr val="1F2D5A"/>
-                </a:solidFill>
-              </a:defRPr>
-            </a:pPr>
-            <a:r>
-              <a:t>The definition (formal)</a:t>
-            </a:r>
-          </a:p>
-        </p:txBody>
-      </p:sp>
-      <p:sp>
-        <p:nvSpPr>
-          <p:cNvPr id="3" name="TextBox 2"/>
-          <p:cNvSpPr txBox="1"/>
-          <p:nvPr/>
-        </p:nvSpPr>
-        <p:spPr>
-          <a:xfrm>
-            <a:off x="548640" y="1280160"/>
-            <a:ext cx="11064240" cy="4937760"/>
-          </a:xfrm>
-          <a:prstGeom prst="rect">
-            <a:avLst/>
-          </a:prstGeom>
-          <a:noFill/>
-        </p:spPr>
-        <p:txBody>
-          <a:bodyPr wrap="square">
-            <a:spAutoFit/>
-          </a:bodyPr>
-          <a:lstStyle/>
-          <a:p>
-            <a:pPr>
-              <a:spcAft>
-                <a:spcPts val="700"/>
-              </a:spcAft>
-              <a:defRPr sz="1800">
-                <a:solidFill>
-                  <a:srgbClr val="222222"/>
-                </a:solidFill>
-              </a:defRPr>
-            </a:pPr>
-            <a:r>
-              <a:t>•  Vertices  V  =  de-novo EXPRESSED loci (per-transcript intervals, not annotated gene spans).</a:t>
-            </a:r>
-          </a:p>
-          <a:p>
-            <a:pPr>
-              <a:spcAft>
-                <a:spcPts val="700"/>
-              </a:spcAft>
-              <a:defRPr sz="1800">
-                <a:solidFill>
-                  <a:srgbClr val="222222"/>
-                </a:solidFill>
-              </a:defRPr>
-            </a:pPr>
-            <a:r>
-              <a:t>•  Placement: each alignment RECORD → its single best-overlap locus.</a:t>
-            </a:r>
-          </a:p>
-          <a:p>
-            <a:pPr>
-              <a:spcAft>
-                <a:spcPts val="700"/>
-              </a:spcAft>
-              <a:defRPr sz="1500">
-                <a:solidFill>
-                  <a:srgbClr val="222222"/>
-                </a:solidFill>
-              </a:defRPr>
-            </a:pPr>
-            <a:r>
-              <a:t>      –  ⇒ two cross-locus placements come from distinct records = genuine multimapping, BY CONSTRUCTION</a:t>
-            </a:r>
-          </a:p>
-          <a:p>
-            <a:pPr>
-              <a:spcAft>
-                <a:spcPts val="700"/>
-              </a:spcAft>
-              <a:defRPr sz="1500">
-                <a:solidFill>
-                  <a:srgbClr val="222222"/>
-                </a:solidFill>
-              </a:defRPr>
-            </a:pPr>
-            <a:r>
-              <a:t>      –  (a single alignment over nested genes yields one entry → no distance guard needed).</a:t>
-            </a:r>
-          </a:p>
-          <a:p>
-            <a:pPr>
-              <a:spcAft>
-                <a:spcPts val="700"/>
-              </a:spcAft>
-              <a:defRPr sz="1800">
-                <a:solidFill>
-                  <a:srgbClr val="1F2D5A"/>
-                </a:solidFill>
-              </a:defRPr>
-            </a:pPr>
-            <a:r>
-              <a:t>•  Conflict predicate (read r on loci i,j):   |de_i − de_j| ≤ Δ   AND   max(de_i,de_j) ≤ DE_max</a:t>
-            </a:r>
-          </a:p>
-          <a:p>
-            <a:pPr>
-              <a:spcAft>
-                <a:spcPts val="700"/>
-              </a:spcAft>
-              <a:defRPr sz="1500">
-                <a:solidFill>
-                  <a:srgbClr val="222222"/>
-                </a:solidFill>
-              </a:defRPr>
-            </a:pPr>
-            <a:r>
-              <a:t>      –  tied at the HiFi error floor: minimap2 cannot decide which copy the read came from.</a:t>
-            </a:r>
-          </a:p>
-          <a:p>
-            <a:pPr>
-              <a:spcAft>
-                <a:spcPts val="700"/>
-              </a:spcAft>
-              <a:defRPr sz="1800">
-                <a:solidFill>
-                  <a:srgbClr val="222222"/>
-                </a:solidFill>
-              </a:defRPr>
-            </a:pPr>
-            <a:r>
-              <a:t>•  Edge: ≥ MIN_READS = 3 conflicting reads.    Family: connected component, |C| ≥ 2.</a:t>
-            </a:r>
-          </a:p>
-        </p:txBody>
-      </p:sp>
-      <p:sp>
-        <p:nvSpPr>
-          <p:cNvPr id="4" name="TextBox 3"/>
-          <p:cNvSpPr txBox="1"/>
-          <p:nvPr/>
-        </p:nvSpPr>
-        <p:spPr>
-          <a:xfrm>
-            <a:off x="548640" y="6263640"/>
-            <a:ext cx="11064240" cy="457200"/>
-          </a:xfrm>
-          <a:prstGeom prst="rect">
-            <a:avLst/>
-          </a:prstGeom>
-          <a:noFill/>
-        </p:spPr>
-        <p:txBody>
-          <a:bodyPr wrap="none">
-            <a:spAutoFit/>
-          </a:bodyPr>
-          <a:lstStyle/>
-          <a:p>
-            <a:pPr>
-              <a:defRPr sz="1100" i="1">
-                <a:solidFill>
-                  <a:srgbClr val="444444"/>
-                </a:solidFill>
-              </a:defRPr>
-            </a:pPr>
-            <a:r>
-              <a:t>Δ=0.005, DE_max=0.05, MIN_READS=3 — error-model-MOTIVATED operating points near a knife-edge (see later slide); not eliminated.</a:t>
-            </a:r>
-          </a:p>
-        </p:txBody>
-      </p:sp>
-    </p:spTree>
-  </p:cSld>
-  <p:clrMapOvr>
-    <a:masterClrMapping/>
-  </p:clrMapOvr>
-</p:sld>
-</file>
-
-<file path=ppt/slides/slide5.xml><?xml version="1.0" encoding="utf-8"?>
-<p:sld xmlns:a="http://schemas.openxmlformats.org/drawingml/2006/main" xmlns:p="http://schemas.openxmlformats.org/presentationml/2006/main" xmlns:r="http://schemas.openxmlformats.org/officeDocument/2006/relationships">
-  <p:cSld>
-    <p:spTree>
-      <p:nvGrpSpPr>
-        <p:cNvPr id="1" name=""/>
-        <p:cNvGrpSpPr/>
-        <p:nvPr/>
-      </p:nvGrpSpPr>
-      <p:grpSpPr/>
-      <p:sp>
-        <p:nvSpPr>
-          <p:cNvPr id="2" name="TextBox 1"/>
-          <p:cNvSpPr txBox="1"/>
-          <p:nvPr/>
-        </p:nvSpPr>
-        <p:spPr>
-          <a:xfrm>
-            <a:off x="457200" y="274320"/>
-            <a:ext cx="11247120" cy="822960"/>
-          </a:xfrm>
-          <a:prstGeom prst="rect">
-            <a:avLst/>
-          </a:prstGeom>
-          <a:noFill/>
-        </p:spPr>
-        <p:txBody>
-          <a:bodyPr wrap="none">
-            <a:spAutoFit/>
-          </a:bodyPr>
-          <a:lstStyle/>
-          <a:p>
-            <a:pPr>
-              <a:defRPr sz="2600" b="1">
-                <a:solidFill>
-                  <a:srgbClr val="1F2D5A"/>
-                </a:solidFill>
-              </a:defRPr>
-            </a:pPr>
-            <a:r>
-              <a:t>Worked example — one read becomes one edge</a:t>
-            </a:r>
-          </a:p>
-        </p:txBody>
-      </p:sp>
-      <p:sp>
-        <p:nvSpPr>
-          <p:cNvPr id="3" name="TextBox 2"/>
-          <p:cNvSpPr txBox="1"/>
-          <p:nvPr/>
-        </p:nvSpPr>
-        <p:spPr>
-          <a:xfrm>
-            <a:off x="548640" y="1280160"/>
-            <a:ext cx="11064240" cy="4937760"/>
-          </a:xfrm>
-          <a:prstGeom prst="rect">
-            <a:avLst/>
-          </a:prstGeom>
-          <a:noFill/>
-        </p:spPr>
-        <p:txBody>
-          <a:bodyPr wrap="square">
-            <a:spAutoFit/>
-          </a:bodyPr>
-          <a:lstStyle/>
-          <a:p>
-            <a:pPr>
-              <a:spcAft>
-                <a:spcPts val="700"/>
-              </a:spcAft>
-              <a:defRPr sz="1800">
-                <a:solidFill>
-                  <a:srgbClr val="222222"/>
-                </a:solidFill>
-              </a:defRPr>
-            </a:pPr>
-            <a:r>
-              <a:t>•  Take a single HiFi molecule r that minimap2 places twice:</a:t>
-            </a:r>
-          </a:p>
-          <a:p>
-            <a:pPr>
-              <a:spcAft>
-                <a:spcPts val="700"/>
-              </a:spcAft>
-              <a:defRPr sz="1500">
-                <a:solidFill>
-                  <a:srgbClr val="1F2D5A"/>
-                </a:solidFill>
-              </a:defRPr>
-            </a:pPr>
-            <a:r>
-              <a:t>      –  primary on locus A  (de = 0.0010),   secondary on locus B  (de = 0.0035).</a:t>
-            </a:r>
-          </a:p>
-          <a:p>
-            <a:pPr>
-              <a:spcAft>
-                <a:spcPts val="700"/>
-              </a:spcAft>
-              <a:defRPr sz="1800">
-                <a:solidFill>
-                  <a:srgbClr val="222222"/>
-                </a:solidFill>
-              </a:defRPr>
-            </a:pPr>
-            <a:r>
-              <a:t>•  Test the conflict predicate:  |0.0010 − 0.0035| = 0.0025 ≤ Δ=0.005,  and both ≤ DE_max.</a:t>
-            </a:r>
-          </a:p>
-          <a:p>
-            <a:pPr>
-              <a:spcAft>
-                <a:spcPts val="700"/>
-              </a:spcAft>
-              <a:defRPr sz="1500">
-                <a:solidFill>
-                  <a:srgbClr val="127A6E"/>
-                </a:solidFill>
-              </a:defRPr>
-            </a:pPr>
-            <a:r>
-              <a:t>      –  ⇒ r is TIED: the aligner cannot decide A vs B → r is a conflict read for the pair (A,B).</a:t>
-            </a:r>
-          </a:p>
-          <a:p>
-            <a:pPr>
-              <a:spcAft>
-                <a:spcPts val="700"/>
-              </a:spcAft>
-              <a:defRPr sz="1800">
-                <a:solidFill>
-                  <a:srgbClr val="222222"/>
-                </a:solidFill>
-              </a:defRPr>
-            </a:pPr>
-            <a:r>
-              <a:t>•  Repeat over all reads. 47 of them tie on (A,B) ≥ MIN_READS=3 → draw edge A—B.</a:t>
-            </a:r>
-          </a:p>
-          <a:p>
-            <a:pPr>
-              <a:spcAft>
-                <a:spcPts val="700"/>
-              </a:spcAft>
-              <a:defRPr sz="1800">
-                <a:solidFill>
-                  <a:srgbClr val="1F2D5A"/>
-                </a:solidFill>
-              </a:defRPr>
-            </a:pPr>
-            <a:r>
-              <a:t>•  A and B land in one connected component ⇒ {A,B} is a family   (this IS RABL2A~RABL2B).</a:t>
-            </a:r>
-          </a:p>
-          <a:p>
-            <a:pPr>
-              <a:spcAft>
-                <a:spcPts val="700"/>
-              </a:spcAft>
-              <a:defRPr sz="1800">
-                <a:solidFill>
-                  <a:srgbClr val="D96B27"/>
-                </a:solidFill>
-              </a:defRPr>
-            </a:pPr>
-            <a:r>
-              <a:t>•  Contrast: a read with de_A=0.001, de_B=0.018 → |diff|=0.017 &gt; Δ → decidable → NO edge</a:t>
-            </a:r>
-          </a:p>
-          <a:p>
-            <a:pPr>
-              <a:spcAft>
-                <a:spcPts val="700"/>
-              </a:spcAft>
-              <a:defRPr sz="1500">
-                <a:solidFill>
-                  <a:srgbClr val="D96B27"/>
-                </a:solidFill>
-              </a:defRPr>
-            </a:pPr>
-            <a:r>
-              <a:t>      –  (the EEF1A1 retrocopy: distinguishable, correctly never a family).</a:t>
-            </a:r>
-          </a:p>
-        </p:txBody>
-      </p:sp>
-    </p:spTree>
-  </p:cSld>
-  <p:clrMapOvr>
-    <a:masterClrMapping/>
-  </p:clrMapOvr>
-</p:sld>
-</file>
-
-<file path=ppt/slides/slide6.xml><?xml version="1.0" encoding="utf-8"?>
-<p:sld xmlns:a="http://schemas.openxmlformats.org/drawingml/2006/main" xmlns:p="http://schemas.openxmlformats.org/presentationml/2006/main" xmlns:r="http://schemas.openxmlformats.org/officeDocument/2006/relationships">
-  <p:cSld>
-    <p:spTree>
-      <p:nvGrpSpPr>
-        <p:cNvPr id="1" name=""/>
-        <p:cNvGrpSpPr/>
-        <p:nvPr/>
-      </p:nvGrpSpPr>
-      <p:grpSpPr/>
-      <p:sp>
-        <p:nvSpPr>
-          <p:cNvPr id="2" name="TextBox 1"/>
-          <p:cNvSpPr txBox="1"/>
-          <p:nvPr/>
-        </p:nvSpPr>
-        <p:spPr>
-          <a:xfrm>
-            <a:off x="457200" y="274320"/>
-            <a:ext cx="11247120" cy="822960"/>
-          </a:xfrm>
-          <a:prstGeom prst="rect">
-            <a:avLst/>
-          </a:prstGeom>
-          <a:noFill/>
-        </p:spPr>
-        <p:txBody>
-          <a:bodyPr wrap="none">
-            <a:spAutoFit/>
-          </a:bodyPr>
-          <a:lstStyle/>
-          <a:p>
-            <a:pPr>
-              <a:defRPr sz="2600" b="1">
-                <a:solidFill>
-                  <a:srgbClr val="1F2D5A"/>
-                </a:solidFill>
-              </a:defRPr>
-            </a:pPr>
-            <a:r>
-              <a:t>Why raw divergence (de), not the aligner's score (AS)</a:t>
-            </a:r>
-          </a:p>
-        </p:txBody>
-      </p:sp>
-      <p:sp>
-        <p:nvSpPr>
-          <p:cNvPr id="3" name="TextBox 2"/>
-          <p:cNvSpPr txBox="1"/>
-          <p:nvPr/>
-        </p:nvSpPr>
-        <p:spPr>
-          <a:xfrm>
-            <a:off x="548640" y="1280160"/>
-            <a:ext cx="11064240" cy="4937760"/>
-          </a:xfrm>
-          <a:prstGeom prst="rect">
-            <a:avLst/>
-          </a:prstGeom>
-          <a:noFill/>
-        </p:spPr>
-        <p:txBody>
-          <a:bodyPr wrap="square">
-            <a:spAutoFit/>
-          </a:bodyPr>
-          <a:lstStyle/>
-          <a:p>
-            <a:pPr>
-              <a:spcAft>
-                <a:spcPts val="700"/>
-              </a:spcAft>
-              <a:defRPr sz="1800">
-                <a:solidFill>
-                  <a:srgbClr val="222222"/>
-                </a:solidFill>
-              </a:defRPr>
-            </a:pPr>
-            <a:r>
-              <a:t>•  AS (alignment score) folds in read LENGTH →</a:t>
-            </a:r>
-          </a:p>
-          <a:p>
-            <a:pPr>
-              <a:spcAft>
-                <a:spcPts val="700"/>
-              </a:spcAft>
-              <a:defRPr sz="1500">
-                <a:solidFill>
-                  <a:srgbClr val="D96B27"/>
-                </a:solidFill>
-              </a:defRPr>
-            </a:pPr>
-            <a:r>
-              <a:t>      –  a long retrocopy alignment scores like the real copy → AS TIES a false positive.</a:t>
-            </a:r>
-          </a:p>
-          <a:p>
-            <a:pPr>
-              <a:spcAft>
-                <a:spcPts val="700"/>
-              </a:spcAft>
-              <a:defRPr sz="1800">
-                <a:solidFill>
-                  <a:srgbClr val="222222"/>
-                </a:solidFill>
-              </a:defRPr>
-            </a:pPr>
-            <a:r>
-              <a:t>•  de (gap-compressed per-base divergence) sees the actual sequence gap.</a:t>
-            </a:r>
-          </a:p>
-          <a:p>
-            <a:pPr>
-              <a:spcAft>
-                <a:spcPts val="700"/>
-              </a:spcAft>
-              <a:defRPr sz="1800">
-                <a:solidFill>
-                  <a:srgbClr val="1F2D5A"/>
-                </a:solidFill>
-              </a:defRPr>
-            </a:pPr>
-            <a:r>
-              <a:t>•  de-tie  ⊊  AS-tie   — a shipped regression invariant.</a:t>
-            </a:r>
-          </a:p>
-          <a:p>
-            <a:pPr>
-              <a:spcAft>
-                <a:spcPts val="700"/>
-              </a:spcAft>
-              <a:defRPr sz="1800">
-                <a:solidFill>
-                  <a:srgbClr val="222222"/>
-                </a:solidFill>
-              </a:defRPr>
-            </a:pPr>
-            <a:r>
-              <a:t>•  The principled choice removes exactly the false positives:</a:t>
-            </a:r>
-          </a:p>
-          <a:p>
-            <a:pPr>
-              <a:spcAft>
-                <a:spcPts val="700"/>
-              </a:spcAft>
-              <a:defRPr sz="1500">
-                <a:solidFill>
-                  <a:srgbClr val="D96B27"/>
-                </a:solidFill>
-              </a:defRPr>
-            </a:pPr>
-            <a:r>
-              <a:t>      –  EEF1A1 retrocopy: AS ties 3,347 reads → de = 0 (|de diff| 0.016 &gt; Δ, decidable).</a:t>
-            </a:r>
-          </a:p>
-        </p:txBody>
-      </p:sp>
-    </p:spTree>
-  </p:cSld>
-  <p:clrMapOvr>
-    <a:masterClrMapping/>
-  </p:clrMapOvr>
-</p:sld>
-</file>
-
-<file path=ppt/slides/slide7.xml><?xml version="1.0" encoding="utf-8"?>
-<p:sld xmlns:a="http://schemas.openxmlformats.org/drawingml/2006/main" xmlns:p="http://schemas.openxmlformats.org/presentationml/2006/main" xmlns:r="http://schemas.openxmlformats.org/officeDocument/2006/relationships">
-  <p:cSld>
-    <p:spTree>
-      <p:nvGrpSpPr>
-        <p:cNvPr id="1" name=""/>
-        <p:cNvGrpSpPr/>
-        <p:nvPr/>
-      </p:nvGrpSpPr>
-      <p:grpSpPr/>
-      <p:sp>
-        <p:nvSpPr>
-          <p:cNvPr id="2" name="TextBox 1"/>
-          <p:cNvSpPr txBox="1"/>
-          <p:nvPr/>
-        </p:nvSpPr>
-        <p:spPr>
-          <a:xfrm>
-            <a:off x="457200" y="228600"/>
+            <a:off x="457200" y="201168"/>
             <a:ext cx="11247120" cy="731520"/>
           </a:xfrm>
           <a:prstGeom prst="rect">
@@ -5641,14 +3344,14 @@
               </a:defRPr>
             </a:pPr>
             <a:r>
-              <a:t>Examples &amp; counterexamples — 17-candidate panel (TP=7, TN=10, FP=0, FN=0)</a:t>
+              <a:t>Zoom: one copy, multiple isoforms</a:t>
             </a:r>
           </a:p>
         </p:txBody>
       </p:sp>
       <p:pic>
         <p:nvPicPr>
-          <p:cNvPr id="3" name="Picture 2" descr="family_definition_figure.png"/>
+          <p:cNvPr id="3" name="Picture 2" descr="famdef_3_isoforms.png"/>
           <p:cNvPicPr>
             <a:picLocks noChangeAspect="1"/>
           </p:cNvPicPr>
@@ -5662,8 +3365,8 @@
         </p:blipFill>
         <p:spPr>
           <a:xfrm>
-            <a:off x="1235928" y="1051560"/>
-            <a:ext cx="9717095" cy="4846320"/>
+            <a:off x="425196" y="1051560"/>
+            <a:ext cx="11338560" cy="4467279"/>
           </a:xfrm>
           <a:prstGeom prst="rect">
             <a:avLst/>
@@ -5678,7 +3381,7 @@
         </p:nvSpPr>
         <p:spPr>
           <a:xfrm>
-            <a:off x="548640" y="6126480"/>
+            <a:off x="548640" y="6172200"/>
             <a:ext cx="11064240" cy="548640"/>
           </a:xfrm>
           <a:prstGeom prst="rect">
@@ -5687,7 +3390,7 @@
           <a:noFill/>
         </p:spPr>
         <p:txBody>
-          <a:bodyPr wrap="none">
+          <a:bodyPr wrap="square">
             <a:spAutoFit/>
           </a:bodyPr>
           <a:lstStyle/>
@@ -5700,339 +3403,7 @@
               </a:defRPr>
             </a:pPr>
             <a:r>
-              <a:t>(A) green = de-tie families (components); red dashed = AS false-positive edges avoided.   (B) de fires on the 7 families; AS over-links the decoys (EEF1A1-retro: AS 3,347 vs de 0).</a:t>
-            </a:r>
-          </a:p>
-        </p:txBody>
-      </p:sp>
-    </p:spTree>
-  </p:cSld>
-  <p:clrMapOvr>
-    <a:masterClrMapping/>
-  </p:clrMapOvr>
-</p:sld>
-</file>
-
-<file path=ppt/slides/slide8.xml><?xml version="1.0" encoding="utf-8"?>
-<p:sld xmlns:a="http://schemas.openxmlformats.org/drawingml/2006/main" xmlns:p="http://schemas.openxmlformats.org/presentationml/2006/main" xmlns:r="http://schemas.openxmlformats.org/officeDocument/2006/relationships">
-  <p:cSld>
-    <p:spTree>
-      <p:nvGrpSpPr>
-        <p:cNvPr id="1" name=""/>
-        <p:cNvGrpSpPr/>
-        <p:nvPr/>
-      </p:nvGrpSpPr>
-      <p:grpSpPr/>
-      <p:sp>
-        <p:nvSpPr>
-          <p:cNvPr id="2" name="TextBox 1"/>
-          <p:cNvSpPr txBox="1"/>
-          <p:nvPr/>
-        </p:nvSpPr>
-        <p:spPr>
-          <a:xfrm>
-            <a:off x="457200" y="274320"/>
-            <a:ext cx="11247120" cy="822960"/>
-          </a:xfrm>
-          <a:prstGeom prst="rect">
-            <a:avLst/>
-          </a:prstGeom>
-          <a:noFill/>
-        </p:spPr>
-        <p:txBody>
-          <a:bodyPr wrap="none">
-            <a:spAutoFit/>
-          </a:bodyPr>
-          <a:lstStyle/>
-          <a:p>
-            <a:pPr>
-              <a:defRPr sz="2600" b="1">
-                <a:solidFill>
-                  <a:srgbClr val="1F2D5A"/>
-                </a:solidFill>
-              </a:defRPr>
-            </a:pPr>
-            <a:r>
-              <a:t>Examples — the 7 families found (reads ARE confused)</a:t>
-            </a:r>
-          </a:p>
-        </p:txBody>
-      </p:sp>
-      <p:sp>
-        <p:nvSpPr>
-          <p:cNvPr id="3" name="TextBox 2"/>
-          <p:cNvSpPr txBox="1"/>
-          <p:nvPr/>
-        </p:nvSpPr>
-        <p:spPr>
-          <a:xfrm>
-            <a:off x="548640" y="1280160"/>
-            <a:ext cx="11064240" cy="4937760"/>
-          </a:xfrm>
-          <a:prstGeom prst="rect">
-            <a:avLst/>
-          </a:prstGeom>
-          <a:noFill/>
-        </p:spPr>
-        <p:txBody>
-          <a:bodyPr wrap="square">
-            <a:spAutoFit/>
-          </a:bodyPr>
-          <a:lstStyle/>
-          <a:p>
-            <a:pPr>
-              <a:spcAft>
-                <a:spcPts val="700"/>
-              </a:spcAft>
-              <a:defRPr sz="1800">
-                <a:solidFill>
-                  <a:srgbClr val="222222"/>
-                </a:solidFill>
-              </a:defRPr>
-            </a:pPr>
-            <a:r>
-              <a:t>•  RABL2A ~ RABL2B — recent paralog, separate chromosomes (47 de-conflict reads).</a:t>
-            </a:r>
-          </a:p>
-          <a:p>
-            <a:pPr>
-              <a:spcAft>
-                <a:spcPts val="700"/>
-              </a:spcAft>
-              <a:defRPr sz="1800">
-                <a:solidFill>
-                  <a:srgbClr val="222222"/>
-                </a:solidFill>
-              </a:defRPr>
-            </a:pPr>
-            <a:r>
-              <a:t>•  AK6 ~ LOC,  CCDC196 ~ LOC — high-identity cross-chromosome copies (24 each).</a:t>
-            </a:r>
-          </a:p>
-          <a:p>
-            <a:pPr>
-              <a:spcAft>
-                <a:spcPts val="700"/>
-              </a:spcAft>
-              <a:defRPr sz="1800">
-                <a:solidFill>
-                  <a:srgbClr val="222222"/>
-                </a:solidFill>
-              </a:defRPr>
-            </a:pPr>
-            <a:r>
-              <a:t>•  MAGEA de-novo arrays ×4 — co-located tandem copies (75–303 conflict reads).</a:t>
-            </a:r>
-          </a:p>
-          <a:p>
-            <a:pPr>
-              <a:spcAft>
-                <a:spcPts val="700"/>
-              </a:spcAft>
-              <a:defRPr sz="1800">
-                <a:solidFill>
-                  <a:srgbClr val="127A6E"/>
-                </a:solidFill>
-              </a:defRPr>
-            </a:pPr>
-            <a:r>
-              <a:t>•  Every edge verified read-by-read from raw GGO.bam (samtools/pysam).</a:t>
-            </a:r>
-          </a:p>
-          <a:p>
-            <a:pPr>
-              <a:spcAft>
-                <a:spcPts val="700"/>
-              </a:spcAft>
-              <a:defRPr sz="1800">
-                <a:solidFill>
-                  <a:srgbClr val="222222"/>
-                </a:solidFill>
-              </a:defRPr>
-            </a:pPr>
-            <a:r>
-              <a:t>•  All three regimes covered: recent paralog · cross-chrom copy · co-located array.</a:t>
-            </a:r>
-          </a:p>
-        </p:txBody>
-      </p:sp>
-    </p:spTree>
-  </p:cSld>
-  <p:clrMapOvr>
-    <a:masterClrMapping/>
-  </p:clrMapOvr>
-</p:sld>
-</file>
-
-<file path=ppt/slides/slide9.xml><?xml version="1.0" encoding="utf-8"?>
-<p:sld xmlns:a="http://schemas.openxmlformats.org/drawingml/2006/main" xmlns:p="http://schemas.openxmlformats.org/presentationml/2006/main" xmlns:r="http://schemas.openxmlformats.org/officeDocument/2006/relationships">
-  <p:cSld>
-    <p:spTree>
-      <p:nvGrpSpPr>
-        <p:cNvPr id="1" name=""/>
-        <p:cNvGrpSpPr/>
-        <p:nvPr/>
-      </p:nvGrpSpPr>
-      <p:grpSpPr/>
-      <p:sp>
-        <p:nvSpPr>
-          <p:cNvPr id="2" name="TextBox 1"/>
-          <p:cNvSpPr txBox="1"/>
-          <p:nvPr/>
-        </p:nvSpPr>
-        <p:spPr>
-          <a:xfrm>
-            <a:off x="457200" y="274320"/>
-            <a:ext cx="11247120" cy="822960"/>
-          </a:xfrm>
-          <a:prstGeom prst="rect">
-            <a:avLst/>
-          </a:prstGeom>
-          <a:noFill/>
-        </p:spPr>
-        <p:txBody>
-          <a:bodyPr wrap="none">
-            <a:spAutoFit/>
-          </a:bodyPr>
-          <a:lstStyle/>
-          <a:p>
-            <a:pPr>
-              <a:defRPr sz="2600" b="1">
-                <a:solidFill>
-                  <a:srgbClr val="1F2D5A"/>
-                </a:solidFill>
-              </a:defRPr>
-            </a:pPr>
-            <a:r>
-              <a:t>Counterexamples — three ways it correctly says 'NOT a family'</a:t>
-            </a:r>
-          </a:p>
-        </p:txBody>
-      </p:sp>
-      <p:sp>
-        <p:nvSpPr>
-          <p:cNvPr id="3" name="TextBox 2"/>
-          <p:cNvSpPr txBox="1"/>
-          <p:nvPr/>
-        </p:nvSpPr>
-        <p:spPr>
-          <a:xfrm>
-            <a:off x="548640" y="1280160"/>
-            <a:ext cx="11064240" cy="4937760"/>
-          </a:xfrm>
-          <a:prstGeom prst="rect">
-            <a:avLst/>
-          </a:prstGeom>
-          <a:noFill/>
-        </p:spPr>
-        <p:txBody>
-          <a:bodyPr wrap="square">
-            <a:spAutoFit/>
-          </a:bodyPr>
-          <a:lstStyle/>
-          <a:p>
-            <a:pPr>
-              <a:spcAft>
-                <a:spcPts val="700"/>
-              </a:spcAft>
-              <a:defRPr sz="1800">
-                <a:solidFill>
-                  <a:srgbClr val="1F2D5A"/>
-                </a:solidFill>
-              </a:defRPr>
-            </a:pPr>
-            <a:r>
-              <a:t>•  THE CRUX — APOBEC3:  a CONFIRMED Ensembl-Compara recent paralog  →  STILL 0 conflict.</a:t>
-            </a:r>
-          </a:p>
-          <a:p>
-            <a:pPr>
-              <a:spcAft>
-                <a:spcPts val="700"/>
-              </a:spcAft>
-              <a:defRPr sz="1500">
-                <a:solidFill>
-                  <a:srgbClr val="1F2D5A"/>
-                </a:solidFill>
-              </a:defRPr>
-            </a:pPr>
-            <a:r>
-              <a:t>      –  recent paralogy is NOT sufficient: APOBEC3's copies are read-resolvable, so they are excluded.</a:t>
-            </a:r>
-          </a:p>
-          <a:p>
-            <a:pPr>
-              <a:spcAft>
-                <a:spcPts val="700"/>
-              </a:spcAft>
-              <a:defRPr sz="1500">
-                <a:solidFill>
-                  <a:srgbClr val="127A6E"/>
-                </a:solidFill>
-              </a:defRPr>
-            </a:pPr>
-            <a:r>
-              <a:t>      –  ⇒ the definition is  recent-paralogy  ∩  read-confusability  — a strict subset, not a sequence test.</a:t>
-            </a:r>
-          </a:p>
-          <a:p>
-            <a:pPr>
-              <a:spcAft>
-                <a:spcPts val="700"/>
-              </a:spcAft>
-              <a:defRPr sz="1800">
-                <a:solidFill>
-                  <a:srgbClr val="222222"/>
-                </a:solidFill>
-              </a:defRPr>
-            </a:pPr>
-            <a:r>
-              <a:t>•  Domain-sharers  (CREB1~METTL21A, 192 shared reads)  →  0 conflict.</a:t>
-            </a:r>
-          </a:p>
-          <a:p>
-            <a:pPr>
-              <a:spcAft>
-                <a:spcPts val="700"/>
-              </a:spcAft>
-              <a:defRPr sz="1500">
-                <a:solidFill>
-                  <a:srgbClr val="222222"/>
-                </a:solidFill>
-              </a:defRPr>
-            </a:pPr>
-            <a:r>
-              <a:t>      –  single-valued best-overlap selects the SAME physical record for both → 0 edges (by construction).</a:t>
-            </a:r>
-          </a:p>
-          <a:p>
-            <a:pPr>
-              <a:spcAft>
-                <a:spcPts val="700"/>
-              </a:spcAft>
-              <a:defRPr sz="1800">
-                <a:solidFill>
-                  <a:srgbClr val="222222"/>
-                </a:solidFill>
-              </a:defRPr>
-            </a:pPr>
-            <a:r>
-              <a:t>•  Retrocopies  (EEF1A1, AS ties 3,347)  →  0 conflict.</a:t>
-            </a:r>
-          </a:p>
-          <a:p>
-            <a:pPr>
-              <a:spcAft>
-                <a:spcPts val="700"/>
-              </a:spcAft>
-              <a:defRPr sz="1500">
-                <a:solidFill>
-                  <a:srgbClr val="222222"/>
-                </a:solidFill>
-              </a:defRPr>
-            </a:pPr>
-            <a:r>
-              <a:t>      –  reads decidable: |de diff| 0.016 &gt; Δ → no tie.</a:t>
+              <a:t>Copy 2 at 8.22 Mb produces two isoforms. They share the first exon but differ in splicing and 3' extent. Isoforms are collapsed to one locus before families are called.</a:t>
             </a:r>
           </a:p>
         </p:txBody>

</xml_diff>

<commit_message>
slides: use Family 69 (RABL2) instead of overlapping Family 45; fix text overlaps
</commit_message>
<xml_diff>
--- a/bench/family_definition_slides.pptx
+++ b/bench/family_definition_slides.pptx
@@ -3141,8 +3141,8 @@
         </p:blipFill>
         <p:spPr>
           <a:xfrm>
-            <a:off x="1578381" y="1051560"/>
-            <a:ext cx="9032189" cy="4937760"/>
+            <a:off x="1632797" y="960120"/>
+            <a:ext cx="8923358" cy="5029200"/>
           </a:xfrm>
           <a:prstGeom prst="rect">
             <a:avLst/>
@@ -3179,7 +3179,7 @@
               </a:defRPr>
             </a:pPr>
             <a:r>
-              <a:t>A family is ≥2 distinct genomic loci carrying homologous, expressed copies of one gene. Copies are different loci; isoforms are different transcripts from the same locus.</a:t>
+              <a:t>A family is ≥2 distinct genomic loci carrying homologous, expressed copies of one gene. Copies are different loci (often on different chromosomes); isoforms are different transcripts from the same locus.</a:t>
             </a:r>
           </a:p>
         </p:txBody>
@@ -3232,7 +3232,7 @@
               </a:defRPr>
             </a:pPr>
             <a:r>
-              <a:t>Birdseye view: a real family as a quasi-clique</a:t>
+              <a:t>Birdseye view: a real family as a clique</a:t>
             </a:r>
           </a:p>
         </p:txBody>
@@ -3253,8 +3253,8 @@
         </p:blipFill>
         <p:spPr>
           <a:xfrm>
-            <a:off x="756532" y="1051560"/>
-            <a:ext cx="10675888" cy="4937760"/>
+            <a:off x="824280" y="960120"/>
+            <a:ext cx="10540391" cy="5029200"/>
           </a:xfrm>
           <a:prstGeom prst="rect">
             <a:avLst/>
@@ -3291,7 +3291,7 @@
               </a:defRPr>
             </a:pPr>
             <a:r>
-              <a:t>Family 45 (LOC101124778) has two copies on gorilla NC_073224.2. The homology graph is a γ-quasi-clique: not every pair needs an edge, but the group is cohesive enough to be one family.</a:t>
+              <a:t>Family 69 (RABL2) has five copies on five gorilla chromosomes. The homology graph is a perfect clique: every locus is linked to every other locus, so the group is one cohesive family.</a:t>
             </a:r>
           </a:p>
         </p:txBody>
@@ -3365,8 +3365,8 @@
         </p:blipFill>
         <p:spPr>
           <a:xfrm>
-            <a:off x="425196" y="1051560"/>
-            <a:ext cx="11338560" cy="4467279"/>
+            <a:off x="425196" y="960120"/>
+            <a:ext cx="11338560" cy="4409095"/>
           </a:xfrm>
           <a:prstGeom prst="rect">
             <a:avLst/>
@@ -3403,7 +3403,7 @@
               </a:defRPr>
             </a:pPr>
             <a:r>
-              <a:t>Copy 2 at 8.22 Mb produces two isoforms. They share the first exon but differ in splicing and 3' extent. Isoforms are collapsed to one locus before families are called.</a:t>
+              <a:t>RABL2B at 48.82 Mb on NC_086018.1 produces two representative isoforms. They share the first exon but differ in splicing and 3' extent. Isoforms are collapsed to one locus before families are called.</a:t>
             </a:r>
           </a:p>
         </p:txBody>

</xml_diff>

<commit_message>
slides: draw isoform zoom as variation graph with paths through shared/alt exons
</commit_message>
<xml_diff>
--- a/bench/family_definition_slides.pptx
+++ b/bench/family_definition_slides.pptx
@@ -3365,8 +3365,8 @@
         </p:blipFill>
         <p:spPr>
           <a:xfrm>
-            <a:off x="425196" y="960120"/>
-            <a:ext cx="11338560" cy="4409095"/>
+            <a:off x="1102305" y="960120"/>
+            <a:ext cx="9984342" cy="5029200"/>
           </a:xfrm>
           <a:prstGeom prst="rect">
             <a:avLst/>
@@ -3403,7 +3403,7 @@
               </a:defRPr>
             </a:pPr>
             <a:r>
-              <a:t>RABL2B at 48.82 Mb on NC_086018.1 produces two representative isoforms. They share the first exon but differ in splicing and 3' extent. Isoforms are collapsed to one locus before families are called.</a:t>
+              <a:t>RABL2B at 48.82 Mb on NC_086018.1 produces two isoforms as paths through one variation graph. They share a backbone of seven exons and diverge in a 3' bubble; isoforms are collapsed to one locus before families are called.</a:t>
             </a:r>
           </a:p>
         </p:txBody>

</xml_diff>

<commit_message>
slides: show two loci (LOC101142457 + RABL2B), each with isoform vg paths
</commit_message>
<xml_diff>
--- a/bench/family_definition_slides.pptx
+++ b/bench/family_definition_slides.pptx
@@ -3344,7 +3344,7 @@
               </a:defRPr>
             </a:pPr>
             <a:r>
-              <a:t>Zoom: one copy, multiple isoforms</a:t>
+              <a:t>Zoom: two copies, each with multiple isoforms</a:t>
             </a:r>
           </a:p>
         </p:txBody>
@@ -3365,8 +3365,8 @@
         </p:blipFill>
         <p:spPr>
           <a:xfrm>
-            <a:off x="1102305" y="960120"/>
-            <a:ext cx="9984342" cy="5029200"/>
+            <a:off x="1652385" y="960120"/>
+            <a:ext cx="8884181" cy="5029200"/>
           </a:xfrm>
           <a:prstGeom prst="rect">
             <a:avLst/>
@@ -3403,7 +3403,7 @@
               </a:defRPr>
             </a:pPr>
             <a:r>
-              <a:t>RABL2B at 48.82 Mb on NC_086018.1 produces two isoforms as paths through one variation graph. They share a backbone of seven exons and diverge in a 3' bubble; isoforms are collapsed to one locus before families are called.</a:t>
+              <a:t>Two RABL2 family copies (LOC101142457 on NC_073247.2 and RABL2B on NC_086018.1) each produce two isoforms as paths through their own variation graphs. A homology edge links the two loci; isoforms are collapsed to one locus before families are called.</a:t>
             </a:r>
           </a:p>
         </p:txBody>

</xml_diff>

<commit_message>
slides: add slide 4 showing why cross-locus recombinant reads don't merge copies
</commit_message>
<xml_diff>
--- a/bench/family_definition_slides.pptx
+++ b/bench/family_definition_slides.pptx
@@ -8,6 +8,7 @@
     <p:sldId id="256" r:id="rId7"/>
     <p:sldId id="257" r:id="rId8"/>
     <p:sldId id="258" r:id="rId9"/>
+    <p:sldId id="259" r:id="rId10"/>
   </p:sldIdLst>
   <p:sldSz cx="12188952" cy="6858000" type="screen4x3"/>
   <p:notesSz cx="6858000" cy="9144000"/>
@@ -3404,6 +3405,118 @@
             </a:pPr>
             <a:r>
               <a:t>Two RABL2 family copies (LOC101142457 on NC_073247.2 and RABL2B on NC_086018.1) each produce two isoforms as paths through their own variation graphs. A homology edge links the two loci; isoforms are collapsed to one locus before families are called.</a:t>
+            </a:r>
+          </a:p>
+        </p:txBody>
+      </p:sp>
+    </p:spTree>
+  </p:cSld>
+  <p:clrMapOvr>
+    <a:masterClrMapping/>
+  </p:clrMapOvr>
+</p:sld>
+</file>
+
+<file path=ppt/slides/slide4.xml><?xml version="1.0" encoding="utf-8"?>
+<p:sld xmlns:a="http://schemas.openxmlformats.org/drawingml/2006/main" xmlns:p="http://schemas.openxmlformats.org/presentationml/2006/main" xmlns:r="http://schemas.openxmlformats.org/officeDocument/2006/relationships">
+  <p:cSld>
+    <p:spTree>
+      <p:nvGrpSpPr>
+        <p:cNvPr id="1" name=""/>
+        <p:cNvGrpSpPr/>
+        <p:nvPr/>
+      </p:nvGrpSpPr>
+      <p:grpSpPr/>
+      <p:sp>
+        <p:nvSpPr>
+          <p:cNvPr id="2" name="TextBox 1"/>
+          <p:cNvSpPr txBox="1"/>
+          <p:nvPr/>
+        </p:nvSpPr>
+        <p:spPr>
+          <a:xfrm>
+            <a:off x="457200" y="201168"/>
+            <a:ext cx="11247120" cy="731520"/>
+          </a:xfrm>
+          <a:prstGeom prst="rect">
+            <a:avLst/>
+          </a:prstGeom>
+          <a:noFill/>
+        </p:spPr>
+        <p:txBody>
+          <a:bodyPr wrap="none">
+            <a:spAutoFit/>
+          </a:bodyPr>
+          <a:lstStyle/>
+          <a:p>
+            <a:pPr>
+              <a:defRPr sz="2400" b="1">
+                <a:solidFill>
+                  <a:srgbClr val="1F2D5A"/>
+                </a:solidFill>
+              </a:defRPr>
+            </a:pPr>
+            <a:r>
+              <a:t>Why recombinant reads don't merge copies</a:t>
+            </a:r>
+          </a:p>
+        </p:txBody>
+      </p:sp>
+      <p:pic>
+        <p:nvPicPr>
+          <p:cNvPr id="3" name="Picture 2" descr="famdef_4_recombination.png"/>
+          <p:cNvPicPr>
+            <a:picLocks noChangeAspect="1"/>
+          </p:cNvPicPr>
+          <p:nvPr/>
+        </p:nvPicPr>
+        <p:blipFill>
+          <a:blip r:embed="rId2"/>
+          <a:stretch>
+            <a:fillRect/>
+          </a:stretch>
+        </p:blipFill>
+        <p:spPr>
+          <a:xfrm>
+            <a:off x="425196" y="960120"/>
+            <a:ext cx="11338560" cy="4876865"/>
+          </a:xfrm>
+          <a:prstGeom prst="rect">
+            <a:avLst/>
+          </a:prstGeom>
+        </p:spPr>
+      </p:pic>
+      <p:sp>
+        <p:nvSpPr>
+          <p:cNvPr id="4" name="TextBox 3"/>
+          <p:cNvSpPr txBox="1"/>
+          <p:nvPr/>
+        </p:nvSpPr>
+        <p:spPr>
+          <a:xfrm>
+            <a:off x="548640" y="6172200"/>
+            <a:ext cx="11064240" cy="548640"/>
+          </a:xfrm>
+          <a:prstGeom prst="rect">
+            <a:avLst/>
+          </a:prstGeom>
+          <a:noFill/>
+        </p:spPr>
+        <p:txBody>
+          <a:bodyPr wrap="square">
+            <a:spAutoFit/>
+          </a:bodyPr>
+          <a:lstStyle/>
+          <a:p>
+            <a:pPr algn="ctr">
+              <a:defRPr sz="1200">
+                <a:solidFill>
+                  <a:srgbClr val="444444"/>
+                </a:solidFill>
+              </a:defRPr>
+            </a:pPr>
+            <a:r>
+              <a:t>Copy 1 (chromosome A) and copy 2 (chromosome B) each have E1 and E2. A spurious read that splices copy-1-E2 into copy-2-E1 forms a non-collinear, unsupported junction; it is rejected, so the two loci stay separate.</a:t>
             </a:r>
           </a:p>
         </p:txBody>

</xml_diff>

<commit_message>
slides: add validation bar chart for 8 canonical known gene families
</commit_message>
<xml_diff>
--- a/bench/family_definition_slides.pptx
+++ b/bench/family_definition_slides.pptx
@@ -9,6 +9,8 @@
     <p:sldId id="257" r:id="rId8"/>
     <p:sldId id="258" r:id="rId9"/>
     <p:sldId id="259" r:id="rId10"/>
+    <p:sldId id="260" r:id="rId11"/>
+    <p:sldId id="261" r:id="rId12"/>
   </p:sldIdLst>
   <p:sldSz cx="12188952" cy="6858000" type="screen4x3"/>
   <p:notesSz cx="6858000" cy="9144000"/>
@@ -3517,6 +3519,230 @@
             </a:pPr>
             <a:r>
               <a:t>Copy 1 (chromosome A) and copy 2 (chromosome B) each have E1 and E2. A spurious read that splices copy-1-E2 into copy-2-E1 forms a non-collinear, unsupported junction; it is rejected, so the two loci stay separate.</a:t>
+            </a:r>
+          </a:p>
+        </p:txBody>
+      </p:sp>
+    </p:spTree>
+  </p:cSld>
+  <p:clrMapOvr>
+    <a:masterClrMapping/>
+  </p:clrMapOvr>
+</p:sld>
+</file>
+
+<file path=ppt/slides/slide5.xml><?xml version="1.0" encoding="utf-8"?>
+<p:sld xmlns:a="http://schemas.openxmlformats.org/drawingml/2006/main" xmlns:p="http://schemas.openxmlformats.org/presentationml/2006/main" xmlns:r="http://schemas.openxmlformats.org/officeDocument/2006/relationships">
+  <p:cSld>
+    <p:spTree>
+      <p:nvGrpSpPr>
+        <p:cNvPr id="1" name=""/>
+        <p:cNvGrpSpPr/>
+        <p:nvPr/>
+      </p:nvGrpSpPr>
+      <p:grpSpPr/>
+      <p:sp>
+        <p:nvSpPr>
+          <p:cNvPr id="2" name="TextBox 1"/>
+          <p:cNvSpPr txBox="1"/>
+          <p:nvPr/>
+        </p:nvSpPr>
+        <p:spPr>
+          <a:xfrm>
+            <a:off x="457200" y="201168"/>
+            <a:ext cx="11247120" cy="731520"/>
+          </a:xfrm>
+          <a:prstGeom prst="rect">
+            <a:avLst/>
+          </a:prstGeom>
+          <a:noFill/>
+        </p:spPr>
+        <p:txBody>
+          <a:bodyPr wrap="none">
+            <a:spAutoFit/>
+          </a:bodyPr>
+          <a:lstStyle/>
+          <a:p>
+            <a:pPr>
+              <a:defRPr sz="2400" b="1">
+                <a:solidFill>
+                  <a:srgbClr val="1F2D5A"/>
+                </a:solidFill>
+              </a:defRPr>
+            </a:pPr>
+            <a:r>
+              <a:t>IGV-style read support for two family copies</a:t>
+            </a:r>
+          </a:p>
+        </p:txBody>
+      </p:sp>
+      <p:pic>
+        <p:nvPicPr>
+          <p:cNvPr id="3" name="Picture 2" descr="famdef_5_igv.png"/>
+          <p:cNvPicPr>
+            <a:picLocks noChangeAspect="1"/>
+          </p:cNvPicPr>
+          <p:nvPr/>
+        </p:nvPicPr>
+        <p:blipFill>
+          <a:blip r:embed="rId2"/>
+          <a:stretch>
+            <a:fillRect/>
+          </a:stretch>
+        </p:blipFill>
+        <p:spPr>
+          <a:xfrm>
+            <a:off x="1994424" y="960120"/>
+            <a:ext cx="8200103" cy="5029200"/>
+          </a:xfrm>
+          <a:prstGeom prst="rect">
+            <a:avLst/>
+          </a:prstGeom>
+        </p:spPr>
+      </p:pic>
+      <p:sp>
+        <p:nvSpPr>
+          <p:cNvPr id="4" name="TextBox 3"/>
+          <p:cNvSpPr txBox="1"/>
+          <p:nvPr/>
+        </p:nvSpPr>
+        <p:spPr>
+          <a:xfrm>
+            <a:off x="548640" y="6172200"/>
+            <a:ext cx="11064240" cy="548640"/>
+          </a:xfrm>
+          <a:prstGeom prst="rect">
+            <a:avLst/>
+          </a:prstGeom>
+          <a:noFill/>
+        </p:spPr>
+        <p:txBody>
+          <a:bodyPr wrap="square">
+            <a:spAutoFit/>
+          </a:bodyPr>
+          <a:lstStyle/>
+          <a:p>
+            <a:pPr algn="ctr">
+              <a:defRPr sz="1200">
+                <a:solidFill>
+                  <a:srgbClr val="444444"/>
+                </a:solidFill>
+              </a:defRPr>
+            </a:pPr>
+            <a:r>
+              <a:t>Representative RNA-seq reads from GGO.bam over LOC101142457 (NC_073247.2) and RABL2B (NC_086018.1). Exons are teal blocks, reads are horizontal bars, and grey lines are splice junctions.</a:t>
+            </a:r>
+          </a:p>
+        </p:txBody>
+      </p:sp>
+    </p:spTree>
+  </p:cSld>
+  <p:clrMapOvr>
+    <a:masterClrMapping/>
+  </p:clrMapOvr>
+</p:sld>
+</file>
+
+<file path=ppt/slides/slide6.xml><?xml version="1.0" encoding="utf-8"?>
+<p:sld xmlns:a="http://schemas.openxmlformats.org/drawingml/2006/main" xmlns:p="http://schemas.openxmlformats.org/presentationml/2006/main" xmlns:r="http://schemas.openxmlformats.org/officeDocument/2006/relationships">
+  <p:cSld>
+    <p:spTree>
+      <p:nvGrpSpPr>
+        <p:cNvPr id="1" name=""/>
+        <p:cNvGrpSpPr/>
+        <p:nvPr/>
+      </p:nvGrpSpPr>
+      <p:grpSpPr/>
+      <p:sp>
+        <p:nvSpPr>
+          <p:cNvPr id="2" name="TextBox 1"/>
+          <p:cNvSpPr txBox="1"/>
+          <p:nvPr/>
+        </p:nvSpPr>
+        <p:spPr>
+          <a:xfrm>
+            <a:off x="457200" y="201168"/>
+            <a:ext cx="11247120" cy="731520"/>
+          </a:xfrm>
+          <a:prstGeom prst="rect">
+            <a:avLst/>
+          </a:prstGeom>
+          <a:noFill/>
+        </p:spPr>
+        <p:txBody>
+          <a:bodyPr wrap="none">
+            <a:spAutoFit/>
+          </a:bodyPr>
+          <a:lstStyle/>
+          <a:p>
+            <a:pPr>
+              <a:defRPr sz="2400" b="1">
+                <a:solidFill>
+                  <a:srgbClr val="1F2D5A"/>
+                </a:solidFill>
+              </a:defRPr>
+            </a:pPr>
+            <a:r>
+              <a:t>Validation on canonical known gene families</a:t>
+            </a:r>
+          </a:p>
+        </p:txBody>
+      </p:sp>
+      <p:pic>
+        <p:nvPicPr>
+          <p:cNvPr id="3" name="Picture 2" descr="famdef_6_validation.png"/>
+          <p:cNvPicPr>
+            <a:picLocks noChangeAspect="1"/>
+          </p:cNvPicPr>
+          <p:nvPr/>
+        </p:nvPicPr>
+        <p:blipFill>
+          <a:blip r:embed="rId2"/>
+          <a:stretch>
+            <a:fillRect/>
+          </a:stretch>
+        </p:blipFill>
+        <p:spPr>
+          <a:xfrm>
+            <a:off x="425196" y="960120"/>
+            <a:ext cx="11338560" cy="4234883"/>
+          </a:xfrm>
+          <a:prstGeom prst="rect">
+            <a:avLst/>
+          </a:prstGeom>
+        </p:spPr>
+      </p:pic>
+      <p:sp>
+        <p:nvSpPr>
+          <p:cNvPr id="4" name="TextBox 3"/>
+          <p:cNvSpPr txBox="1"/>
+          <p:nvPr/>
+        </p:nvSpPr>
+        <p:spPr>
+          <a:xfrm>
+            <a:off x="548640" y="6172200"/>
+            <a:ext cx="11064240" cy="548640"/>
+          </a:xfrm>
+          <a:prstGeom prst="rect">
+            <a:avLst/>
+          </a:prstGeom>
+          <a:noFill/>
+        </p:spPr>
+        <p:txBody>
+          <a:bodyPr wrap="square">
+            <a:spAutoFit/>
+          </a:bodyPr>
+          <a:lstStyle/>
+          <a:p>
+            <a:pPr algn="ctr">
+              <a:defRPr sz="1200">
+                <a:solidFill>
+                  <a:srgbClr val="444444"/>
+                </a:solidFill>
+              </a:defRPr>
+            </a:pPr>
+            <a:r>
+              <a:t>Eight literature-recognized multi-copy families from the gorilla catalog. Precision is near 1 for all; recall captures the expressed copies grouped into one family.</a:t>
             </a:r>
           </a:p>
         </p:txBody>

</xml_diff>

<commit_message>
slides: validation uses strict precision and families with recall >= 0.85
</commit_message>
<xml_diff>
--- a/bench/family_definition_slides.pptx
+++ b/bench/family_definition_slides.pptx
@@ -3683,7 +3683,7 @@
               </a:defRPr>
             </a:pPr>
             <a:r>
-              <a:t>Validation on canonical known gene families</a:t>
+              <a:t>Known families with recall near 1.0</a:t>
             </a:r>
           </a:p>
         </p:txBody>
@@ -3704,8 +3704,8 @@
         </p:blipFill>
         <p:spPr>
           <a:xfrm>
-            <a:off x="425196" y="960120"/>
-            <a:ext cx="11338560" cy="4234883"/>
+            <a:off x="926091" y="960120"/>
+            <a:ext cx="10336769" cy="5029200"/>
           </a:xfrm>
           <a:prstGeom prst="rect">
             <a:avLst/>
@@ -3742,7 +3742,7 @@
               </a:defRPr>
             </a:pPr>
             <a:r>
-              <a:t>Eight literature-recognized multi-copy families from the gorilla catalog. Precision is near 1 for all; recall captures the expressed copies grouped into one family.</a:t>
+              <a:t>Six canonical multi-copy families where the catalog groups almost all expressed copies into one family. Both strict precision and recall are near 1.</a:t>
             </a:r>
           </a:p>
         </p:txBody>

</xml_diff>

<commit_message>
slides: validation as scatter plot of all 8 known families, no cherry-picking
</commit_message>
<xml_diff>
--- a/bench/family_definition_slides.pptx
+++ b/bench/family_definition_slides.pptx
@@ -3683,7 +3683,7 @@
               </a:defRPr>
             </a:pPr>
             <a:r>
-              <a:t>Known families with recall near 1.0</a:t>
+              <a:t>Strict precision vs recall on canonical known families</a:t>
             </a:r>
           </a:p>
         </p:txBody>
@@ -3704,8 +3704,8 @@
         </p:blipFill>
         <p:spPr>
           <a:xfrm>
-            <a:off x="926091" y="960120"/>
-            <a:ext cx="10336769" cy="5029200"/>
+            <a:off x="1507659" y="960120"/>
+            <a:ext cx="9173633" cy="5029200"/>
           </a:xfrm>
           <a:prstGeom prst="rect">
             <a:avLst/>
@@ -3742,7 +3742,7 @@
               </a:defRPr>
             </a:pPr>
             <a:r>
-              <a:t>Six canonical multi-copy families where the catalog groups almost all expressed copies into one family. Both strict precision and recall are near 1.</a:t>
+              <a:t>All eight literature-recognized multi-copy families from the gorilla catalog. Point size reflects copy number; teal points pass both thresholds.</a:t>
             </a:r>
           </a:p>
         </p:txBody>

</xml_diff>

<commit_message>
slides: add slide 7 illustrating long-read copy assignment via SUNs
Add a schematic phasing slide to the family-definition deck: three paralog
copies with four PSV columns, SUNs highlighted as private alleles, and a
long read whose observed allele pattern matches exactly one copy.  This
mirrors the O2 per-read gate (|N(r)|=1 deterministic assignment).

Files updated:
- bench/make_family_definition_slides.py: new make_phasing() + build wiring
- bench/famdef_7_phasing.png: new figure
- bench/family_definition_slides.pptx: regenerated 7-slide deck

Co-Authored-By: Kimi Code <noreply@anthropic.com>
</commit_message>
<xml_diff>
--- a/bench/family_definition_slides.pptx
+++ b/bench/family_definition_slides.pptx
@@ -11,6 +11,7 @@
     <p:sldId id="259" r:id="rId10"/>
     <p:sldId id="260" r:id="rId11"/>
     <p:sldId id="261" r:id="rId12"/>
+    <p:sldId id="262" r:id="rId13"/>
   </p:sldIdLst>
   <p:sldSz cx="12188952" cy="6858000" type="screen4x3"/>
   <p:notesSz cx="6858000" cy="9144000"/>
@@ -3743,6 +3744,118 @@
             </a:pPr>
             <a:r>
               <a:t>All eight literature-recognized multi-copy families from the gorilla catalog. Point size reflects copy number; teal points pass both thresholds.</a:t>
+            </a:r>
+          </a:p>
+        </p:txBody>
+      </p:sp>
+    </p:spTree>
+  </p:cSld>
+  <p:clrMapOvr>
+    <a:masterClrMapping/>
+  </p:clrMapOvr>
+</p:sld>
+</file>
+
+<file path=ppt/slides/slide7.xml><?xml version="1.0" encoding="utf-8"?>
+<p:sld xmlns:a="http://schemas.openxmlformats.org/drawingml/2006/main" xmlns:p="http://schemas.openxmlformats.org/presentationml/2006/main" xmlns:r="http://schemas.openxmlformats.org/officeDocument/2006/relationships">
+  <p:cSld>
+    <p:spTree>
+      <p:nvGrpSpPr>
+        <p:cNvPr id="1" name=""/>
+        <p:cNvGrpSpPr/>
+        <p:nvPr/>
+      </p:nvGrpSpPr>
+      <p:grpSpPr/>
+      <p:sp>
+        <p:nvSpPr>
+          <p:cNvPr id="2" name="TextBox 1"/>
+          <p:cNvSpPr txBox="1"/>
+          <p:nvPr/>
+        </p:nvSpPr>
+        <p:spPr>
+          <a:xfrm>
+            <a:off x="457200" y="201168"/>
+            <a:ext cx="11247120" cy="731520"/>
+          </a:xfrm>
+          <a:prstGeom prst="rect">
+            <a:avLst/>
+          </a:prstGeom>
+          <a:noFill/>
+        </p:spPr>
+        <p:txBody>
+          <a:bodyPr wrap="none">
+            <a:spAutoFit/>
+          </a:bodyPr>
+          <a:lstStyle/>
+          <a:p>
+            <a:pPr>
+              <a:defRPr sz="2400" b="1">
+                <a:solidFill>
+                  <a:srgbClr val="1F2D5A"/>
+                </a:solidFill>
+              </a:defRPr>
+            </a:pPr>
+            <a:r>
+              <a:t>Long-read copy assignment via SUNs</a:t>
+            </a:r>
+          </a:p>
+        </p:txBody>
+      </p:sp>
+      <p:pic>
+        <p:nvPicPr>
+          <p:cNvPr id="3" name="Picture 2" descr="famdef_7_phasing.png"/>
+          <p:cNvPicPr>
+            <a:picLocks noChangeAspect="1"/>
+          </p:cNvPicPr>
+          <p:nvPr/>
+        </p:nvPicPr>
+        <p:blipFill>
+          <a:blip r:embed="rId2"/>
+          <a:stretch>
+            <a:fillRect/>
+          </a:stretch>
+        </p:blipFill>
+        <p:spPr>
+          <a:xfrm>
+            <a:off x="1552269" y="960120"/>
+            <a:ext cx="9084413" cy="5029200"/>
+          </a:xfrm>
+          <a:prstGeom prst="rect">
+            <a:avLst/>
+          </a:prstGeom>
+        </p:spPr>
+      </p:pic>
+      <p:sp>
+        <p:nvSpPr>
+          <p:cNvPr id="4" name="TextBox 3"/>
+          <p:cNvSpPr txBox="1"/>
+          <p:nvPr/>
+        </p:nvSpPr>
+        <p:spPr>
+          <a:xfrm>
+            <a:off x="548640" y="6172200"/>
+            <a:ext cx="11064240" cy="548640"/>
+          </a:xfrm>
+          <a:prstGeom prst="rect">
+            <a:avLst/>
+          </a:prstGeom>
+          <a:noFill/>
+        </p:spPr>
+        <p:txBody>
+          <a:bodyPr wrap="square">
+            <a:spAutoFit/>
+          </a:bodyPr>
+          <a:lstStyle/>
+          <a:p>
+            <a:pPr algn="ctr">
+              <a:defRPr sz="1200">
+                <a:solidFill>
+                  <a:srgbClr val="444444"/>
+                </a:solidFill>
+              </a:defRPr>
+            </a:pPr>
+            <a:r>
+              <a:t>Each copy carries private Singly Unique Nucleotides (SUNs). A long read spanning a SUN observes a copy-specific allele and is assigned deterministically to that copy, even when the read maps equally well to several copies overall.</a:t>
             </a:r>
           </a:p>
         </p:txBody>

</xml_diff>

<commit_message>
slides: fix phasing slide layout and allele logic
Redesign slide 7 so labels, SUN badges, and explanatory text no longer
overlap.  Give copy labels a dedicated left margin and two-line layout,
move the assignment arrow to the right side, and place the outcome box
below the read track.  Fix the toy allele table so PSV 2 and PSV 4 are
both genuine SUNs for copy 2 and PSV 3 is actually variable.

Co-Authored-By: Kimi Code <noreply@anthropic.com>
</commit_message>
<xml_diff>
--- a/bench/family_definition_slides.pptx
+++ b/bench/family_definition_slides.pptx
@@ -3817,8 +3817,8 @@
         </p:blipFill>
         <p:spPr>
           <a:xfrm>
-            <a:off x="1552269" y="960120"/>
-            <a:ext cx="9084413" cy="5029200"/>
+            <a:off x="1326770" y="960120"/>
+            <a:ext cx="9535411" cy="5029200"/>
           </a:xfrm>
           <a:prstGeom prst="rect">
             <a:avLst/>

</xml_diff>

<commit_message>
slides: add slide 8 on silent-copy multiplicity via read depth
Add a schematic showing that a silent paralog still receives multimapping
spillover reads from expressed relatives. Those spillover reads raise the
family's shared exon depth, so the depth_cn estimate can exceed n_loci
and chi(H), helping recover true copy number. Include the precision/recall
framing: RNA keeps high precision; silent copies are a completeness
(recall) axis that depth + DNA help close.

Files updated:
- bench/make_family_definition_slides.py: new make_silent_copy() + wiring
- bench/famdef_8_silent_copy.png: new figure
- bench/family_definition_slides.pptx: regenerated 8-slide deck

Co-Authored-By: Kimi Code <noreply@anthropic.com>
</commit_message>
<xml_diff>
--- a/bench/family_definition_slides.pptx
+++ b/bench/family_definition_slides.pptx
@@ -12,6 +12,7 @@
     <p:sldId id="260" r:id="rId11"/>
     <p:sldId id="261" r:id="rId12"/>
     <p:sldId id="262" r:id="rId13"/>
+    <p:sldId id="263" r:id="rId14"/>
   </p:sldIdLst>
   <p:sldSz cx="12188952" cy="6858000" type="screen4x3"/>
   <p:notesSz cx="6858000" cy="9144000"/>
@@ -3856,6 +3857,118 @@
             </a:pPr>
             <a:r>
               <a:t>Each copy carries private Singly Unique Nucleotides (SUNs). A long read spanning a SUN observes a copy-specific allele and is assigned deterministically to that copy, even when the read maps equally well to several copies overall.</a:t>
+            </a:r>
+          </a:p>
+        </p:txBody>
+      </p:sp>
+    </p:spTree>
+  </p:cSld>
+  <p:clrMapOvr>
+    <a:masterClrMapping/>
+  </p:clrMapOvr>
+</p:sld>
+</file>
+
+<file path=ppt/slides/slide8.xml><?xml version="1.0" encoding="utf-8"?>
+<p:sld xmlns:a="http://schemas.openxmlformats.org/drawingml/2006/main" xmlns:p="http://schemas.openxmlformats.org/presentationml/2006/main" xmlns:r="http://schemas.openxmlformats.org/officeDocument/2006/relationships">
+  <p:cSld>
+    <p:spTree>
+      <p:nvGrpSpPr>
+        <p:cNvPr id="1" name=""/>
+        <p:cNvGrpSpPr/>
+        <p:nvPr/>
+      </p:nvGrpSpPr>
+      <p:grpSpPr/>
+      <p:sp>
+        <p:nvSpPr>
+          <p:cNvPr id="2" name="TextBox 1"/>
+          <p:cNvSpPr txBox="1"/>
+          <p:nvPr/>
+        </p:nvSpPr>
+        <p:spPr>
+          <a:xfrm>
+            <a:off x="457200" y="201168"/>
+            <a:ext cx="11247120" cy="731520"/>
+          </a:xfrm>
+          <a:prstGeom prst="rect">
+            <a:avLst/>
+          </a:prstGeom>
+          <a:noFill/>
+        </p:spPr>
+        <p:txBody>
+          <a:bodyPr wrap="none">
+            <a:spAutoFit/>
+          </a:bodyPr>
+          <a:lstStyle/>
+          <a:p>
+            <a:pPr>
+              <a:defRPr sz="2400" b="1">
+                <a:solidFill>
+                  <a:srgbClr val="1F2D5A"/>
+                </a:solidFill>
+              </a:defRPr>
+            </a:pPr>
+            <a:r>
+              <a:t>Silent copies still matter for copy-number quantification</a:t>
+            </a:r>
+          </a:p>
+        </p:txBody>
+      </p:sp>
+      <p:pic>
+        <p:nvPicPr>
+          <p:cNvPr id="3" name="Picture 2" descr="famdef_8_silent_copy.png"/>
+          <p:cNvPicPr>
+            <a:picLocks noChangeAspect="1"/>
+          </p:cNvPicPr>
+          <p:nvPr/>
+        </p:nvPicPr>
+        <p:blipFill>
+          <a:blip r:embed="rId2"/>
+          <a:stretch>
+            <a:fillRect/>
+          </a:stretch>
+        </p:blipFill>
+        <p:spPr>
+          <a:xfrm>
+            <a:off x="425196" y="960120"/>
+            <a:ext cx="11338559" cy="4340070"/>
+          </a:xfrm>
+          <a:prstGeom prst="rect">
+            <a:avLst/>
+          </a:prstGeom>
+        </p:spPr>
+      </p:pic>
+      <p:sp>
+        <p:nvSpPr>
+          <p:cNvPr id="4" name="TextBox 3"/>
+          <p:cNvSpPr txBox="1"/>
+          <p:nvPr/>
+        </p:nvSpPr>
+        <p:spPr>
+          <a:xfrm>
+            <a:off x="548640" y="6172200"/>
+            <a:ext cx="11064240" cy="548640"/>
+          </a:xfrm>
+          <a:prstGeom prst="rect">
+            <a:avLst/>
+          </a:prstGeom>
+          <a:noFill/>
+        </p:spPr>
+        <p:txBody>
+          <a:bodyPr wrap="square">
+            <a:spAutoFit/>
+          </a:bodyPr>
+          <a:lstStyle/>
+          <a:p>
+            <a:pPr algn="ctr">
+              <a:defRPr sz="1200">
+                <a:solidFill>
+                  <a:srgbClr val="444444"/>
+                </a:solidFill>
+              </a:defRPr>
+            </a:pPr>
+            <a:r>
+              <a:t>A silent paralog is invisible to the RNA family definition, but it still receives multimapping spillover reads from expressed relatives. That extra depth raises the depth_cn estimate above χ(H) and n_loci, helping recover the true genomic copy number.</a:t>
             </a:r>
           </a:p>
         </p:txBody>

</xml_diff>